<commit_message>
chore: finelli-praesentation pptx auf V2.1 Stand (Folie 2 AB-SOFORT-Band)
Co-Authored-By: Claude Fable 5 <noreply@anthropic.com>
</commit_message>
<xml_diff>
--- a/kunden/finelli/praesentation/finelli-praesentation-2026-07-20.pptx
+++ b/kunden/finelli/praesentation/finelli-praesentation-2026-07-20.pptx
@@ -8299,8 +8299,8 @@
         </p:nvSpPr>
         <p:spPr>
           <a:xfrm>
-            <a:off x="914400" y="4709160"/>
-            <a:ext cx="3566160" cy="1097280"/>
+            <a:off x="914400" y="4526280"/>
+            <a:ext cx="2743200" cy="457200"/>
           </a:xfrm>
           <a:prstGeom prst="rect">
             <a:avLst/>
@@ -8319,112 +8319,27 @@
               </a:spcAft>
             </a:pPr>
             <a:r>
-              <a:rPr sz="3800" b="1">
-                <a:solidFill>
-                  <a:srgbClr val="FFFFFF"/>
-                </a:solidFill>
-                <a:latin typeface="Georgia"/>
-              </a:rPr>
-              <a:t>54 bis 65 %</a:t>
-            </a:r>
-          </a:p>
-        </p:txBody>
-      </p:sp>
-      <p:sp>
-        <p:nvSpPr>
-          <p:cNvPr id="14" name="TextBox 13"/>
-          <p:cNvSpPr txBox="1"/>
-          <p:nvPr/>
-        </p:nvSpPr>
-        <p:spPr>
-          <a:xfrm>
-            <a:off x="4389120" y="4663440"/>
-            <a:ext cx="6949440" cy="548640"/>
-          </a:xfrm>
-          <a:prstGeom prst="rect">
-            <a:avLst/>
-          </a:prstGeom>
-          <a:noFill/>
-        </p:spPr>
-        <p:txBody>
-          <a:bodyPr wrap="square" anchor="t">
-            <a:spAutoFit/>
-          </a:bodyPr>
-          <a:lstStyle/>
-          <a:p>
-            <a:pPr algn="l">
-              <a:spcAft>
-                <a:spcPts val="600"/>
-              </a:spcAft>
-            </a:pPr>
-            <a:r>
-              <a:rPr sz="1600" b="1">
-                <a:solidFill>
-                  <a:srgbClr val="FFFFFF"/>
-                </a:solidFill>
-                <a:latin typeface="Segoe UI"/>
-              </a:rPr>
-              <a:t>aller Bestandszahlen im Handel sind falsch.</a:t>
-            </a:r>
-          </a:p>
-        </p:txBody>
-      </p:sp>
-      <p:sp>
-        <p:nvSpPr>
-          <p:cNvPr id="15" name="Rounded Rectangle 14"/>
+              <a:rPr sz="1300" b="1">
+                <a:solidFill>
+                  <a:srgbClr val="F0C9C3"/>
+                </a:solidFill>
+                <a:latin typeface="Segoe UI"/>
+              </a:rPr>
+              <a:t>AB SOFORT</a:t>
+            </a:r>
+          </a:p>
+        </p:txBody>
+      </p:sp>
+      <p:sp>
+        <p:nvSpPr>
+          <p:cNvPr id="14" name="Rounded Rectangle 13"/>
           <p:cNvSpPr/>
           <p:nvPr/>
         </p:nvSpPr>
         <p:spPr>
           <a:xfrm>
-            <a:off x="4389120" y="5349240"/>
-            <a:ext cx="6035040" cy="274320"/>
-          </a:xfrm>
-          <a:prstGeom prst="roundRect">
-            <a:avLst>
-              <a:gd name="adj" fmla="val 50000"/>
-            </a:avLst>
-          </a:prstGeom>
-          <a:solidFill>
-            <a:srgbClr val="3A3841"/>
-          </a:solidFill>
-          <a:ln>
-            <a:noFill/>
-          </a:ln>
-          <a:effectLst/>
-        </p:spPr>
-        <p:style>
-          <a:lnRef idx="1">
-            <a:schemeClr val="accent1"/>
-          </a:lnRef>
-          <a:fillRef idx="3">
-            <a:schemeClr val="accent1"/>
-          </a:fillRef>
-          <a:effectRef idx="2">
-            <a:schemeClr val="accent1"/>
-          </a:effectRef>
-          <a:fontRef idx="minor">
-            <a:schemeClr val="lt1"/>
-          </a:fontRef>
-        </p:style>
-        <p:txBody>
-          <a:bodyPr rtlCol="0" anchor="ctr"/>
-          <a:lstStyle/>
-          <a:p>
-            <a:pPr algn="ctr"/>
-          </a:p>
-        </p:txBody>
-      </p:sp>
-      <p:sp>
-        <p:nvSpPr>
-          <p:cNvPr id="16" name="Rounded Rectangle 15"/>
-          <p:cNvSpPr/>
-          <p:nvPr/>
-        </p:nvSpPr>
-        <p:spPr>
-          <a:xfrm>
-            <a:off x="4389120" y="5349240"/>
-            <a:ext cx="3621024" cy="274320"/>
+            <a:off x="914400" y="5029200"/>
+            <a:ext cx="109728" cy="685800"/>
           </a:xfrm>
           <a:prstGeom prst="roundRect">
             <a:avLst>
@@ -8463,14 +8378,99 @@
       </p:sp>
       <p:sp>
         <p:nvSpPr>
+          <p:cNvPr id="15" name="TextBox 14"/>
+          <p:cNvSpPr txBox="1"/>
+          <p:nvPr/>
+        </p:nvSpPr>
+        <p:spPr>
+          <a:xfrm>
+            <a:off x="1188720" y="5029200"/>
+            <a:ext cx="3154680" cy="1005840"/>
+          </a:xfrm>
+          <a:prstGeom prst="rect">
+            <a:avLst/>
+          </a:prstGeom>
+          <a:noFill/>
+        </p:spPr>
+        <p:txBody>
+          <a:bodyPr wrap="square" anchor="t">
+            <a:spAutoFit/>
+          </a:bodyPr>
+          <a:lstStyle/>
+          <a:p>
+            <a:pPr algn="l">
+              <a:spcAft>
+                <a:spcPts val="600"/>
+              </a:spcAft>
+            </a:pPr>
+            <a:r>
+              <a:rPr sz="1600" b="1">
+                <a:solidFill>
+                  <a:srgbClr val="FFFFFF"/>
+                </a:solidFill>
+                <a:latin typeface="Segoe UI"/>
+              </a:rPr>
+              <a:t>Der Bestand stimmt. Jeder Verkauf hält.</a:t>
+            </a:r>
+          </a:p>
+        </p:txBody>
+      </p:sp>
+      <p:sp>
+        <p:nvSpPr>
+          <p:cNvPr id="16" name="Rounded Rectangle 15"/>
+          <p:cNvSpPr/>
+          <p:nvPr/>
+        </p:nvSpPr>
+        <p:spPr>
+          <a:xfrm>
+            <a:off x="4480560" y="5029200"/>
+            <a:ext cx="109728" cy="685800"/>
+          </a:xfrm>
+          <a:prstGeom prst="roundRect">
+            <a:avLst>
+              <a:gd name="adj" fmla="val 50000"/>
+            </a:avLst>
+          </a:prstGeom>
+          <a:solidFill>
+            <a:srgbClr val="A8271C"/>
+          </a:solidFill>
+          <a:ln>
+            <a:noFill/>
+          </a:ln>
+          <a:effectLst/>
+        </p:spPr>
+        <p:style>
+          <a:lnRef idx="1">
+            <a:schemeClr val="accent1"/>
+          </a:lnRef>
+          <a:fillRef idx="3">
+            <a:schemeClr val="accent1"/>
+          </a:fillRef>
+          <a:effectRef idx="2">
+            <a:schemeClr val="accent1"/>
+          </a:effectRef>
+          <a:fontRef idx="minor">
+            <a:schemeClr val="lt1"/>
+          </a:fontRef>
+        </p:style>
+        <p:txBody>
+          <a:bodyPr rtlCol="0" anchor="ctr"/>
+          <a:lstStyle/>
+          <a:p>
+            <a:pPr algn="ctr"/>
+          </a:p>
+        </p:txBody>
+      </p:sp>
+      <p:sp>
+        <p:nvSpPr>
           <p:cNvPr id="17" name="TextBox 16"/>
           <p:cNvSpPr txBox="1"/>
           <p:nvPr/>
         </p:nvSpPr>
         <p:spPr>
           <a:xfrm>
-            <a:off x="4389120" y="5760720"/>
-            <a:ext cx="6949440" cy="365760"/>
+            <a:off x="4754880" y="5029200"/>
+            <a:ext cx="3154680" cy="1005840"/>
           </a:xfrm>
           <a:prstGeom prst="rect">
             <a:avLst/>
@@ -8489,13 +8489,98 @@
               </a:spcAft>
             </a:pPr>
             <a:r>
-              <a:rPr sz="1050" b="0">
-                <a:solidFill>
-                  <a:srgbClr val="9A97A0"/>
-                </a:solidFill>
-                <a:latin typeface="Segoe UI"/>
-              </a:rPr>
-              <a:t>Quelle: DeHoratius/Raman 2008 · ECR/Cardiff 2019</a:t>
+              <a:rPr sz="1600" b="1">
+                <a:solidFill>
+                  <a:srgbClr val="FFFFFF"/>
+                </a:solidFill>
+                <a:latin typeface="Segoe UI"/>
+              </a:rPr>
+              <a:t>Beide Standorte auf einen Blick.</a:t>
+            </a:r>
+          </a:p>
+        </p:txBody>
+      </p:sp>
+      <p:sp>
+        <p:nvSpPr>
+          <p:cNvPr id="18" name="Rounded Rectangle 17"/>
+          <p:cNvSpPr/>
+          <p:nvPr/>
+        </p:nvSpPr>
+        <p:spPr>
+          <a:xfrm>
+            <a:off x="8046720" y="5029200"/>
+            <a:ext cx="109728" cy="685800"/>
+          </a:xfrm>
+          <a:prstGeom prst="roundRect">
+            <a:avLst>
+              <a:gd name="adj" fmla="val 50000"/>
+            </a:avLst>
+          </a:prstGeom>
+          <a:solidFill>
+            <a:srgbClr val="A8271C"/>
+          </a:solidFill>
+          <a:ln>
+            <a:noFill/>
+          </a:ln>
+          <a:effectLst/>
+        </p:spPr>
+        <p:style>
+          <a:lnRef idx="1">
+            <a:schemeClr val="accent1"/>
+          </a:lnRef>
+          <a:fillRef idx="3">
+            <a:schemeClr val="accent1"/>
+          </a:fillRef>
+          <a:effectRef idx="2">
+            <a:schemeClr val="accent1"/>
+          </a:effectRef>
+          <a:fontRef idx="minor">
+            <a:schemeClr val="lt1"/>
+          </a:fontRef>
+        </p:style>
+        <p:txBody>
+          <a:bodyPr rtlCol="0" anchor="ctr"/>
+          <a:lstStyle/>
+          <a:p>
+            <a:pPr algn="ctr"/>
+          </a:p>
+        </p:txBody>
+      </p:sp>
+      <p:sp>
+        <p:nvSpPr>
+          <p:cNvPr id="19" name="TextBox 18"/>
+          <p:cNvSpPr txBox="1"/>
+          <p:nvPr/>
+        </p:nvSpPr>
+        <p:spPr>
+          <a:xfrm>
+            <a:off x="8321040" y="5029200"/>
+            <a:ext cx="3154680" cy="1005840"/>
+          </a:xfrm>
+          <a:prstGeom prst="rect">
+            <a:avLst/>
+          </a:prstGeom>
+          <a:noFill/>
+        </p:spPr>
+        <p:txBody>
+          <a:bodyPr wrap="square" anchor="t">
+            <a:spAutoFit/>
+          </a:bodyPr>
+          <a:lstStyle/>
+          <a:p>
+            <a:pPr algn="l">
+              <a:spcAft>
+                <a:spcPts val="600"/>
+              </a:spcAft>
+            </a:pPr>
+            <a:r>
+              <a:rPr sz="1600" b="1">
+                <a:solidFill>
+                  <a:srgbClr val="FFFFFF"/>
+                </a:solidFill>
+                <a:latin typeface="Segoe UI"/>
+              </a:rPr>
+              <a:t>Die Kasse rechnet sich selbst ab.</a:t>
             </a:r>
           </a:p>
         </p:txBody>

</xml_diff>

<commit_message>
chore: finelli-praesentation pptx auf V2.2 (ohne Shopify-Nennung)
Co-Authored-By: Claude Fable 5 <noreply@anthropic.com>
</commit_message>
<xml_diff>
--- a/kunden/finelli/praesentation/finelli-praesentation-2026-07-20.pptx
+++ b/kunden/finelli/praesentation/finelli-praesentation-2026-07-20.pptx
@@ -8231,7 +8231,7 @@
                 </a:solidFill>
                 <a:latin typeface="Segoe UI"/>
               </a:rPr>
-              <a:t>Ladenverkäufe werden von Hand in Shopify nachgetragen. </a:t>
+              <a:t>Ladenverkäufe werden von Hand im Onlineshop nachgetragen. </a:t>
             </a:r>
             <a:r>
               <a:rPr sz="1300" b="1">
@@ -8945,7 +8945,7 @@
                 </a:solidFill>
                 <a:latin typeface="Georgia"/>
               </a:rPr>
-              <a:t>Shopify bleibt führend.</a:t>
+              <a:t>Kein Unterbruch.</a:t>
             </a:r>
           </a:p>
           <a:p>
@@ -8961,7 +8961,7 @@
                 </a:solidFill>
                 <a:latin typeface="Segoe UI"/>
               </a:rPr>
-              <a:t>Wir ersetzen nichts. Das Cockpit setzt auf deine bestehenden Systeme auf.</a:t>
+              <a:t>Die Einführung läuft im Hintergrund. Laden und Onlineshop verkaufen jeden Tag normal weiter.</a:t>
             </a:r>
           </a:p>
         </p:txBody>
@@ -10768,7 +10768,7 @@
                 </a:solidFill>
                 <a:latin typeface="Segoe UI"/>
               </a:rPr>
-              <a:t>Shopify</a:t>
+              <a:t>Onlineshop</a:t>
             </a:r>
           </a:p>
         </p:txBody>
@@ -15425,7 +15425,7 @@
                 </a:solidFill>
                 <a:latin typeface="Segoe UI"/>
               </a:rPr>
-              <a:t>Wir verbinden das Cockpit mit deinem Shopify. Shopify bleibt führend.</a:t>
+              <a:t>Wir verbinden das Cockpit mit Onlineshop, Kasse und Versand. Alles läuft in einem System zusammen.</a:t>
             </a:r>
           </a:p>
         </p:txBody>

</xml_diff>

<commit_message>
chore: offene Praesentations-WIP committen (cowork v3)
Sichert die neue Praesentation (Stand 07-21), die geaenderte 07-20 und den
Handoff nach GitHub, damit ai-firma aktuell und der Arbeitsbaum sauber ist.
README und Vorlage-Vorlage bleiben auf dem gepushten Stand; lokale Abweichungen
liegen als Sicherheitsnetz in stash@{0}.

Co-Authored-By: Claude Opus 4.8 (1M context) <noreply@anthropic.com>
</commit_message>
<xml_diff>
--- a/kunden/finelli/praesentation/finelli-praesentation-2026-07-20.pptx
+++ b/kunden/finelli/praesentation/finelli-praesentation-2026-07-20.pptx
@@ -316,7 +316,7 @@
           <a:p>
             <a:fld id="{5BCAD085-E8A6-8845-BD4E-CB4CCA059FC4}" type="datetimeFigureOut">
               <a:rPr lang="en-US" smtClean="0"/>
-              <a:t>7/20/2026</a:t>
+              <a:t>7/21/2026</a:t>
             </a:fld>
             <a:endParaRPr lang="en-US"/>
           </a:p>
@@ -484,7 +484,7 @@
           <a:p>
             <a:fld id="{5BCAD085-E8A6-8845-BD4E-CB4CCA059FC4}" type="datetimeFigureOut">
               <a:rPr lang="en-US" smtClean="0"/>
-              <a:t>7/20/2026</a:t>
+              <a:t>7/21/2026</a:t>
             </a:fld>
             <a:endParaRPr lang="en-US"/>
           </a:p>
@@ -662,7 +662,7 @@
           <a:p>
             <a:fld id="{5BCAD085-E8A6-8845-BD4E-CB4CCA059FC4}" type="datetimeFigureOut">
               <a:rPr lang="en-US" smtClean="0"/>
-              <a:t>7/20/2026</a:t>
+              <a:t>7/21/2026</a:t>
             </a:fld>
             <a:endParaRPr lang="en-US"/>
           </a:p>
@@ -830,7 +830,7 @@
           <a:p>
             <a:fld id="{5BCAD085-E8A6-8845-BD4E-CB4CCA059FC4}" type="datetimeFigureOut">
               <a:rPr lang="en-US" smtClean="0"/>
-              <a:t>7/20/2026</a:t>
+              <a:t>7/21/2026</a:t>
             </a:fld>
             <a:endParaRPr lang="en-US"/>
           </a:p>
@@ -1075,7 +1075,7 @@
           <a:p>
             <a:fld id="{5BCAD085-E8A6-8845-BD4E-CB4CCA059FC4}" type="datetimeFigureOut">
               <a:rPr lang="en-US" smtClean="0"/>
-              <a:t>7/20/2026</a:t>
+              <a:t>7/21/2026</a:t>
             </a:fld>
             <a:endParaRPr lang="en-US"/>
           </a:p>
@@ -1360,7 +1360,7 @@
           <a:p>
             <a:fld id="{5BCAD085-E8A6-8845-BD4E-CB4CCA059FC4}" type="datetimeFigureOut">
               <a:rPr lang="en-US" smtClean="0"/>
-              <a:t>7/20/2026</a:t>
+              <a:t>7/21/2026</a:t>
             </a:fld>
             <a:endParaRPr lang="en-US"/>
           </a:p>
@@ -1779,7 +1779,7 @@
           <a:p>
             <a:fld id="{5BCAD085-E8A6-8845-BD4E-CB4CCA059FC4}" type="datetimeFigureOut">
               <a:rPr lang="en-US" smtClean="0"/>
-              <a:t>7/20/2026</a:t>
+              <a:t>7/21/2026</a:t>
             </a:fld>
             <a:endParaRPr lang="en-US"/>
           </a:p>
@@ -1896,7 +1896,7 @@
           <a:p>
             <a:fld id="{5BCAD085-E8A6-8845-BD4E-CB4CCA059FC4}" type="datetimeFigureOut">
               <a:rPr lang="en-US" smtClean="0"/>
-              <a:t>7/20/2026</a:t>
+              <a:t>7/21/2026</a:t>
             </a:fld>
             <a:endParaRPr lang="en-US"/>
           </a:p>
@@ -1991,7 +1991,7 @@
           <a:p>
             <a:fld id="{5BCAD085-E8A6-8845-BD4E-CB4CCA059FC4}" type="datetimeFigureOut">
               <a:rPr lang="en-US" smtClean="0"/>
-              <a:t>7/20/2026</a:t>
+              <a:t>7/21/2026</a:t>
             </a:fld>
             <a:endParaRPr lang="en-US"/>
           </a:p>
@@ -2266,7 +2266,7 @@
           <a:p>
             <a:fld id="{5BCAD085-E8A6-8845-BD4E-CB4CCA059FC4}" type="datetimeFigureOut">
               <a:rPr lang="en-US" smtClean="0"/>
-              <a:t>7/20/2026</a:t>
+              <a:t>7/21/2026</a:t>
             </a:fld>
             <a:endParaRPr lang="en-US"/>
           </a:p>
@@ -2518,7 +2518,7 @@
           <a:p>
             <a:fld id="{5BCAD085-E8A6-8845-BD4E-CB4CCA059FC4}" type="datetimeFigureOut">
               <a:rPr lang="en-US" smtClean="0"/>
-              <a:t>7/20/2026</a:t>
+              <a:t>7/21/2026</a:t>
             </a:fld>
             <a:endParaRPr lang="en-US"/>
           </a:p>
@@ -2729,7 +2729,7 @@
           <a:p>
             <a:fld id="{5BCAD085-E8A6-8845-BD4E-CB4CCA059FC4}" type="datetimeFigureOut">
               <a:rPr lang="en-US" smtClean="0"/>
-              <a:t>7/20/2026</a:t>
+              <a:t>7/21/2026</a:t>
             </a:fld>
             <a:endParaRPr lang="en-US"/>
           </a:p>
@@ -3284,7 +3284,7 @@
         <p:spPr>
           <a:xfrm>
             <a:off x="1097280" y="2148840"/>
-            <a:ext cx="10058400" cy="1371600"/>
+            <a:ext cx="2767104" cy="984885"/>
           </a:xfrm>
           <a:prstGeom prst="rect">
             <a:avLst/>
@@ -3298,7 +3298,7 @@
           <a:lstStyle/>
           <a:p>
             <a:r>
-              <a:rPr sz="5800" b="1">
+              <a:rPr sz="5800" b="1" dirty="0">
                 <a:solidFill>
                   <a:srgbClr val="F4F0FB"/>
                 </a:solidFill>
@@ -3306,14 +3306,11 @@
               </a:rPr>
               <a:t>FINELLI</a:t>
             </a:r>
-            <a:r>
-              <a:rPr sz="3200">
-                <a:solidFill>
-                  <a:srgbClr val="BB92FF"/>
-                </a:solidFill>
-              </a:rPr>
-              <a:t> ●</a:t>
-            </a:r>
+            <a:endParaRPr sz="3200" dirty="0">
+              <a:solidFill>
+                <a:srgbClr val="BB92FF"/>
+              </a:solidFill>
+            </a:endParaRPr>
           </a:p>
         </p:txBody>
       </p:sp>
@@ -3447,1070 +3444,18 @@
   <p:clrMapOvr>
     <a:masterClrMapping/>
   </p:clrMapOvr>
-  <mc:AlternateContent xmlns:mc="http://schemas.openxmlformats.org/markup-compatibility/2006">
-    <mc:Choice xmlns:p14="http://schemas.microsoft.com/office/powerpoint/2010/main" Requires="p14">
+  <mc:AlternateContent xmlns:mc="http://schemas.openxmlformats.org/markup-compatibility/2006" xmlns:p14="http://schemas.microsoft.com/office/powerpoint/2010/main">
+    <mc:Choice Requires="p14">
       <p:transition spd="med" p14:dur="700">
         <p14:reveal/>
       </p:transition>
     </mc:Choice>
-    <mc:Fallback>
+    <mc:Fallback xmlns="">
       <p:transition spd="med">
         <p:fade/>
       </p:transition>
     </mc:Fallback>
   </mc:AlternateContent>
-  <p:timing>
-    <p:tnLst>
-      <p:par>
-        <p:cTn id="1" dur="indefinite" restart="never" nodeType="tmRoot">
-          <p:childTnLst>
-            <p:seq concurrent="1" nextAc="seek">
-              <p:cTn id="2" dur="indefinite" nodeType="mainSeq">
-                <p:childTnLst>
-                  <p:par>
-                    <p:cTn id="3" fill="hold">
-                      <p:stCondLst>
-                        <p:cond delay="indefinite"/>
-                        <p:cond evt="onBegin" delay="0">
-                          <p:tn val="2"/>
-                        </p:cond>
-                      </p:stCondLst>
-                      <p:childTnLst>
-                        <p:par>
-                          <p:cTn id="4" fill="hold">
-                            <p:stCondLst>
-                              <p:cond delay="0"/>
-                            </p:stCondLst>
-                            <p:childTnLst>
-                              <p:par>
-                                <p:cTn id="5" presetID="30" presetClass="entr" presetSubtype="0" fill="hold" grpId="0" nodeType="withEffect">
-                                  <p:stCondLst>
-                                    <p:cond delay="0"/>
-                                  </p:stCondLst>
-                                  <p:childTnLst>
-                                    <p:set>
-                                      <p:cBhvr>
-                                        <p:cTn id="6" dur="1" fill="hold">
-                                          <p:stCondLst>
-                                            <p:cond delay="0"/>
-                                          </p:stCondLst>
-                                        </p:cTn>
-                                        <p:tgtEl>
-                                          <p:spTgt spid="3"/>
-                                        </p:tgtEl>
-                                        <p:attrNameLst>
-                                          <p:attrName>style.visibility</p:attrName>
-                                        </p:attrNameLst>
-                                      </p:cBhvr>
-                                      <p:to>
-                                        <p:strVal val="visible"/>
-                                      </p:to>
-                                    </p:set>
-                                    <p:animEffect transition="in" filter="fade">
-                                      <p:cBhvr>
-                                        <p:cTn id="7" dur="400" decel="100000"/>
-                                        <p:tgtEl>
-                                          <p:spTgt spid="3"/>
-                                        </p:tgtEl>
-                                      </p:cBhvr>
-                                    </p:animEffect>
-                                    <p:anim calcmode="lin" valueType="num">
-                                      <p:cBhvr>
-                                        <p:cTn id="8" dur="400" decel="100000" fill="hold"/>
-                                        <p:tgtEl>
-                                          <p:spTgt spid="3"/>
-                                        </p:tgtEl>
-                                        <p:attrNameLst>
-                                          <p:attrName>style.rotation</p:attrName>
-                                        </p:attrNameLst>
-                                      </p:cBhvr>
-                                      <p:tavLst>
-                                        <p:tav tm="0">
-                                          <p:val>
-                                            <p:fltVal val="-90"/>
-                                          </p:val>
-                                        </p:tav>
-                                        <p:tav tm="100000">
-                                          <p:val>
-                                            <p:fltVal val="0"/>
-                                          </p:val>
-                                        </p:tav>
-                                      </p:tavLst>
-                                    </p:anim>
-                                    <p:anim calcmode="lin" valueType="num">
-                                      <p:cBhvr>
-                                        <p:cTn id="9" dur="400" decel="100000" fill="hold"/>
-                                        <p:tgtEl>
-                                          <p:spTgt spid="3"/>
-                                        </p:tgtEl>
-                                        <p:attrNameLst>
-                                          <p:attrName>ppt_x</p:attrName>
-                                        </p:attrNameLst>
-                                      </p:cBhvr>
-                                      <p:tavLst>
-                                        <p:tav tm="0">
-                                          <p:val>
-                                            <p:strVal val="#ppt_x+0.4"/>
-                                          </p:val>
-                                        </p:tav>
-                                        <p:tav tm="100000">
-                                          <p:val>
-                                            <p:strVal val="#ppt_x-0.05"/>
-                                          </p:val>
-                                        </p:tav>
-                                      </p:tavLst>
-                                    </p:anim>
-                                    <p:anim calcmode="lin" valueType="num">
-                                      <p:cBhvr>
-                                        <p:cTn id="10" dur="400" decel="100000" fill="hold"/>
-                                        <p:tgtEl>
-                                          <p:spTgt spid="3"/>
-                                        </p:tgtEl>
-                                        <p:attrNameLst>
-                                          <p:attrName>ppt_y</p:attrName>
-                                        </p:attrNameLst>
-                                      </p:cBhvr>
-                                      <p:tavLst>
-                                        <p:tav tm="0">
-                                          <p:val>
-                                            <p:strVal val="#ppt_y-0.4"/>
-                                          </p:val>
-                                        </p:tav>
-                                        <p:tav tm="100000">
-                                          <p:val>
-                                            <p:strVal val="#ppt_y+0.1"/>
-                                          </p:val>
-                                        </p:tav>
-                                      </p:tavLst>
-                                    </p:anim>
-                                    <p:anim calcmode="lin" valueType="num">
-                                      <p:cBhvr>
-                                        <p:cTn id="11" dur="100" accel="100000" fill="hold">
-                                          <p:stCondLst>
-                                            <p:cond delay="400"/>
-                                          </p:stCondLst>
-                                        </p:cTn>
-                                        <p:tgtEl>
-                                          <p:spTgt spid="3"/>
-                                        </p:tgtEl>
-                                        <p:attrNameLst>
-                                          <p:attrName>ppt_x</p:attrName>
-                                        </p:attrNameLst>
-                                      </p:cBhvr>
-                                      <p:tavLst>
-                                        <p:tav tm="0">
-                                          <p:val>
-                                            <p:strVal val="#ppt_x-0.05"/>
-                                          </p:val>
-                                        </p:tav>
-                                        <p:tav tm="100000">
-                                          <p:val>
-                                            <p:strVal val="#ppt_x"/>
-                                          </p:val>
-                                        </p:tav>
-                                      </p:tavLst>
-                                    </p:anim>
-                                    <p:anim calcmode="lin" valueType="num">
-                                      <p:cBhvr>
-                                        <p:cTn id="12" dur="100" accel="100000" fill="hold">
-                                          <p:stCondLst>
-                                            <p:cond delay="400"/>
-                                          </p:stCondLst>
-                                        </p:cTn>
-                                        <p:tgtEl>
-                                          <p:spTgt spid="3"/>
-                                        </p:tgtEl>
-                                        <p:attrNameLst>
-                                          <p:attrName>ppt_y</p:attrName>
-                                        </p:attrNameLst>
-                                      </p:cBhvr>
-                                      <p:tavLst>
-                                        <p:tav tm="0">
-                                          <p:val>
-                                            <p:strVal val="#ppt_y+0.1"/>
-                                          </p:val>
-                                        </p:tav>
-                                        <p:tav tm="100000">
-                                          <p:val>
-                                            <p:strVal val="#ppt_y"/>
-                                          </p:val>
-                                        </p:tav>
-                                      </p:tavLst>
-                                    </p:anim>
-                                  </p:childTnLst>
-                                </p:cTn>
-                              </p:par>
-                            </p:childTnLst>
-                          </p:cTn>
-                        </p:par>
-                        <p:par>
-                          <p:cTn id="13" fill="hold">
-                            <p:stCondLst>
-                              <p:cond delay="500"/>
-                            </p:stCondLst>
-                            <p:childTnLst>
-                              <p:par>
-                                <p:cTn id="14" presetID="30" presetClass="entr" presetSubtype="0" fill="hold" grpId="0" nodeType="afterEffect">
-                                  <p:stCondLst>
-                                    <p:cond delay="40"/>
-                                  </p:stCondLst>
-                                  <p:childTnLst>
-                                    <p:set>
-                                      <p:cBhvr>
-                                        <p:cTn id="15" dur="1" fill="hold">
-                                          <p:stCondLst>
-                                            <p:cond delay="0"/>
-                                          </p:stCondLst>
-                                        </p:cTn>
-                                        <p:tgtEl>
-                                          <p:spTgt spid="4"/>
-                                        </p:tgtEl>
-                                        <p:attrNameLst>
-                                          <p:attrName>style.visibility</p:attrName>
-                                        </p:attrNameLst>
-                                      </p:cBhvr>
-                                      <p:to>
-                                        <p:strVal val="visible"/>
-                                      </p:to>
-                                    </p:set>
-                                    <p:animEffect transition="in" filter="fade">
-                                      <p:cBhvr>
-                                        <p:cTn id="16" dur="400" decel="100000"/>
-                                        <p:tgtEl>
-                                          <p:spTgt spid="4"/>
-                                        </p:tgtEl>
-                                      </p:cBhvr>
-                                    </p:animEffect>
-                                    <p:anim calcmode="lin" valueType="num">
-                                      <p:cBhvr>
-                                        <p:cTn id="17" dur="400" decel="100000" fill="hold"/>
-                                        <p:tgtEl>
-                                          <p:spTgt spid="4"/>
-                                        </p:tgtEl>
-                                        <p:attrNameLst>
-                                          <p:attrName>style.rotation</p:attrName>
-                                        </p:attrNameLst>
-                                      </p:cBhvr>
-                                      <p:tavLst>
-                                        <p:tav tm="0">
-                                          <p:val>
-                                            <p:fltVal val="-90"/>
-                                          </p:val>
-                                        </p:tav>
-                                        <p:tav tm="100000">
-                                          <p:val>
-                                            <p:fltVal val="0"/>
-                                          </p:val>
-                                        </p:tav>
-                                      </p:tavLst>
-                                    </p:anim>
-                                    <p:anim calcmode="lin" valueType="num">
-                                      <p:cBhvr>
-                                        <p:cTn id="18" dur="400" decel="100000" fill="hold"/>
-                                        <p:tgtEl>
-                                          <p:spTgt spid="4"/>
-                                        </p:tgtEl>
-                                        <p:attrNameLst>
-                                          <p:attrName>ppt_x</p:attrName>
-                                        </p:attrNameLst>
-                                      </p:cBhvr>
-                                      <p:tavLst>
-                                        <p:tav tm="0">
-                                          <p:val>
-                                            <p:strVal val="#ppt_x+0.4"/>
-                                          </p:val>
-                                        </p:tav>
-                                        <p:tav tm="100000">
-                                          <p:val>
-                                            <p:strVal val="#ppt_x-0.05"/>
-                                          </p:val>
-                                        </p:tav>
-                                      </p:tavLst>
-                                    </p:anim>
-                                    <p:anim calcmode="lin" valueType="num">
-                                      <p:cBhvr>
-                                        <p:cTn id="19" dur="400" decel="100000" fill="hold"/>
-                                        <p:tgtEl>
-                                          <p:spTgt spid="4"/>
-                                        </p:tgtEl>
-                                        <p:attrNameLst>
-                                          <p:attrName>ppt_y</p:attrName>
-                                        </p:attrNameLst>
-                                      </p:cBhvr>
-                                      <p:tavLst>
-                                        <p:tav tm="0">
-                                          <p:val>
-                                            <p:strVal val="#ppt_y-0.4"/>
-                                          </p:val>
-                                        </p:tav>
-                                        <p:tav tm="100000">
-                                          <p:val>
-                                            <p:strVal val="#ppt_y+0.1"/>
-                                          </p:val>
-                                        </p:tav>
-                                      </p:tavLst>
-                                    </p:anim>
-                                    <p:anim calcmode="lin" valueType="num">
-                                      <p:cBhvr>
-                                        <p:cTn id="20" dur="100" accel="100000" fill="hold">
-                                          <p:stCondLst>
-                                            <p:cond delay="400"/>
-                                          </p:stCondLst>
-                                        </p:cTn>
-                                        <p:tgtEl>
-                                          <p:spTgt spid="4"/>
-                                        </p:tgtEl>
-                                        <p:attrNameLst>
-                                          <p:attrName>ppt_x</p:attrName>
-                                        </p:attrNameLst>
-                                      </p:cBhvr>
-                                      <p:tavLst>
-                                        <p:tav tm="0">
-                                          <p:val>
-                                            <p:strVal val="#ppt_x-0.05"/>
-                                          </p:val>
-                                        </p:tav>
-                                        <p:tav tm="100000">
-                                          <p:val>
-                                            <p:strVal val="#ppt_x"/>
-                                          </p:val>
-                                        </p:tav>
-                                      </p:tavLst>
-                                    </p:anim>
-                                    <p:anim calcmode="lin" valueType="num">
-                                      <p:cBhvr>
-                                        <p:cTn id="21" dur="100" accel="100000" fill="hold">
-                                          <p:stCondLst>
-                                            <p:cond delay="400"/>
-                                          </p:stCondLst>
-                                        </p:cTn>
-                                        <p:tgtEl>
-                                          <p:spTgt spid="4"/>
-                                        </p:tgtEl>
-                                        <p:attrNameLst>
-                                          <p:attrName>ppt_y</p:attrName>
-                                        </p:attrNameLst>
-                                      </p:cBhvr>
-                                      <p:tavLst>
-                                        <p:tav tm="0">
-                                          <p:val>
-                                            <p:strVal val="#ppt_y+0.1"/>
-                                          </p:val>
-                                        </p:tav>
-                                        <p:tav tm="100000">
-                                          <p:val>
-                                            <p:strVal val="#ppt_y"/>
-                                          </p:val>
-                                        </p:tav>
-                                      </p:tavLst>
-                                    </p:anim>
-                                  </p:childTnLst>
-                                </p:cTn>
-                              </p:par>
-                            </p:childTnLst>
-                          </p:cTn>
-                        </p:par>
-                        <p:par>
-                          <p:cTn id="22" fill="hold">
-                            <p:stCondLst>
-                              <p:cond delay="1040"/>
-                            </p:stCondLst>
-                            <p:childTnLst>
-                              <p:par>
-                                <p:cTn id="23" presetID="30" presetClass="entr" presetSubtype="0" fill="hold" grpId="0" nodeType="afterEffect">
-                                  <p:stCondLst>
-                                    <p:cond delay="80"/>
-                                  </p:stCondLst>
-                                  <p:childTnLst>
-                                    <p:set>
-                                      <p:cBhvr>
-                                        <p:cTn id="24" dur="1" fill="hold">
-                                          <p:stCondLst>
-                                            <p:cond delay="0"/>
-                                          </p:stCondLst>
-                                        </p:cTn>
-                                        <p:tgtEl>
-                                          <p:spTgt spid="5"/>
-                                        </p:tgtEl>
-                                        <p:attrNameLst>
-                                          <p:attrName>style.visibility</p:attrName>
-                                        </p:attrNameLst>
-                                      </p:cBhvr>
-                                      <p:to>
-                                        <p:strVal val="visible"/>
-                                      </p:to>
-                                    </p:set>
-                                    <p:animEffect transition="in" filter="fade">
-                                      <p:cBhvr>
-                                        <p:cTn id="25" dur="400" decel="100000"/>
-                                        <p:tgtEl>
-                                          <p:spTgt spid="5"/>
-                                        </p:tgtEl>
-                                      </p:cBhvr>
-                                    </p:animEffect>
-                                    <p:anim calcmode="lin" valueType="num">
-                                      <p:cBhvr>
-                                        <p:cTn id="26" dur="400" decel="100000" fill="hold"/>
-                                        <p:tgtEl>
-                                          <p:spTgt spid="5"/>
-                                        </p:tgtEl>
-                                        <p:attrNameLst>
-                                          <p:attrName>style.rotation</p:attrName>
-                                        </p:attrNameLst>
-                                      </p:cBhvr>
-                                      <p:tavLst>
-                                        <p:tav tm="0">
-                                          <p:val>
-                                            <p:fltVal val="-90"/>
-                                          </p:val>
-                                        </p:tav>
-                                        <p:tav tm="100000">
-                                          <p:val>
-                                            <p:fltVal val="0"/>
-                                          </p:val>
-                                        </p:tav>
-                                      </p:tavLst>
-                                    </p:anim>
-                                    <p:anim calcmode="lin" valueType="num">
-                                      <p:cBhvr>
-                                        <p:cTn id="27" dur="400" decel="100000" fill="hold"/>
-                                        <p:tgtEl>
-                                          <p:spTgt spid="5"/>
-                                        </p:tgtEl>
-                                        <p:attrNameLst>
-                                          <p:attrName>ppt_x</p:attrName>
-                                        </p:attrNameLst>
-                                      </p:cBhvr>
-                                      <p:tavLst>
-                                        <p:tav tm="0">
-                                          <p:val>
-                                            <p:strVal val="#ppt_x+0.4"/>
-                                          </p:val>
-                                        </p:tav>
-                                        <p:tav tm="100000">
-                                          <p:val>
-                                            <p:strVal val="#ppt_x-0.05"/>
-                                          </p:val>
-                                        </p:tav>
-                                      </p:tavLst>
-                                    </p:anim>
-                                    <p:anim calcmode="lin" valueType="num">
-                                      <p:cBhvr>
-                                        <p:cTn id="28" dur="400" decel="100000" fill="hold"/>
-                                        <p:tgtEl>
-                                          <p:spTgt spid="5"/>
-                                        </p:tgtEl>
-                                        <p:attrNameLst>
-                                          <p:attrName>ppt_y</p:attrName>
-                                        </p:attrNameLst>
-                                      </p:cBhvr>
-                                      <p:tavLst>
-                                        <p:tav tm="0">
-                                          <p:val>
-                                            <p:strVal val="#ppt_y-0.4"/>
-                                          </p:val>
-                                        </p:tav>
-                                        <p:tav tm="100000">
-                                          <p:val>
-                                            <p:strVal val="#ppt_y+0.1"/>
-                                          </p:val>
-                                        </p:tav>
-                                      </p:tavLst>
-                                    </p:anim>
-                                    <p:anim calcmode="lin" valueType="num">
-                                      <p:cBhvr>
-                                        <p:cTn id="29" dur="100" accel="100000" fill="hold">
-                                          <p:stCondLst>
-                                            <p:cond delay="400"/>
-                                          </p:stCondLst>
-                                        </p:cTn>
-                                        <p:tgtEl>
-                                          <p:spTgt spid="5"/>
-                                        </p:tgtEl>
-                                        <p:attrNameLst>
-                                          <p:attrName>ppt_x</p:attrName>
-                                        </p:attrNameLst>
-                                      </p:cBhvr>
-                                      <p:tavLst>
-                                        <p:tav tm="0">
-                                          <p:val>
-                                            <p:strVal val="#ppt_x-0.05"/>
-                                          </p:val>
-                                        </p:tav>
-                                        <p:tav tm="100000">
-                                          <p:val>
-                                            <p:strVal val="#ppt_x"/>
-                                          </p:val>
-                                        </p:tav>
-                                      </p:tavLst>
-                                    </p:anim>
-                                    <p:anim calcmode="lin" valueType="num">
-                                      <p:cBhvr>
-                                        <p:cTn id="30" dur="100" accel="100000" fill="hold">
-                                          <p:stCondLst>
-                                            <p:cond delay="400"/>
-                                          </p:stCondLst>
-                                        </p:cTn>
-                                        <p:tgtEl>
-                                          <p:spTgt spid="5"/>
-                                        </p:tgtEl>
-                                        <p:attrNameLst>
-                                          <p:attrName>ppt_y</p:attrName>
-                                        </p:attrNameLst>
-                                      </p:cBhvr>
-                                      <p:tavLst>
-                                        <p:tav tm="0">
-                                          <p:val>
-                                            <p:strVal val="#ppt_y+0.1"/>
-                                          </p:val>
-                                        </p:tav>
-                                        <p:tav tm="100000">
-                                          <p:val>
-                                            <p:strVal val="#ppt_y"/>
-                                          </p:val>
-                                        </p:tav>
-                                      </p:tavLst>
-                                    </p:anim>
-                                  </p:childTnLst>
-                                </p:cTn>
-                              </p:par>
-                            </p:childTnLst>
-                          </p:cTn>
-                        </p:par>
-                        <p:par>
-                          <p:cTn id="31" fill="hold">
-                            <p:stCondLst>
-                              <p:cond delay="1620"/>
-                            </p:stCondLst>
-                            <p:childTnLst>
-                              <p:par>
-                                <p:cTn id="32" presetID="30" presetClass="entr" presetSubtype="0" fill="hold" grpId="0" nodeType="afterEffect">
-                                  <p:stCondLst>
-                                    <p:cond delay="120"/>
-                                  </p:stCondLst>
-                                  <p:childTnLst>
-                                    <p:set>
-                                      <p:cBhvr>
-                                        <p:cTn id="33" dur="1" fill="hold">
-                                          <p:stCondLst>
-                                            <p:cond delay="0"/>
-                                          </p:stCondLst>
-                                        </p:cTn>
-                                        <p:tgtEl>
-                                          <p:spTgt spid="6"/>
-                                        </p:tgtEl>
-                                        <p:attrNameLst>
-                                          <p:attrName>style.visibility</p:attrName>
-                                        </p:attrNameLst>
-                                      </p:cBhvr>
-                                      <p:to>
-                                        <p:strVal val="visible"/>
-                                      </p:to>
-                                    </p:set>
-                                    <p:animEffect transition="in" filter="fade">
-                                      <p:cBhvr>
-                                        <p:cTn id="34" dur="400" decel="100000"/>
-                                        <p:tgtEl>
-                                          <p:spTgt spid="6"/>
-                                        </p:tgtEl>
-                                      </p:cBhvr>
-                                    </p:animEffect>
-                                    <p:anim calcmode="lin" valueType="num">
-                                      <p:cBhvr>
-                                        <p:cTn id="35" dur="400" decel="100000" fill="hold"/>
-                                        <p:tgtEl>
-                                          <p:spTgt spid="6"/>
-                                        </p:tgtEl>
-                                        <p:attrNameLst>
-                                          <p:attrName>style.rotation</p:attrName>
-                                        </p:attrNameLst>
-                                      </p:cBhvr>
-                                      <p:tavLst>
-                                        <p:tav tm="0">
-                                          <p:val>
-                                            <p:fltVal val="-90"/>
-                                          </p:val>
-                                        </p:tav>
-                                        <p:tav tm="100000">
-                                          <p:val>
-                                            <p:fltVal val="0"/>
-                                          </p:val>
-                                        </p:tav>
-                                      </p:tavLst>
-                                    </p:anim>
-                                    <p:anim calcmode="lin" valueType="num">
-                                      <p:cBhvr>
-                                        <p:cTn id="36" dur="400" decel="100000" fill="hold"/>
-                                        <p:tgtEl>
-                                          <p:spTgt spid="6"/>
-                                        </p:tgtEl>
-                                        <p:attrNameLst>
-                                          <p:attrName>ppt_x</p:attrName>
-                                        </p:attrNameLst>
-                                      </p:cBhvr>
-                                      <p:tavLst>
-                                        <p:tav tm="0">
-                                          <p:val>
-                                            <p:strVal val="#ppt_x+0.4"/>
-                                          </p:val>
-                                        </p:tav>
-                                        <p:tav tm="100000">
-                                          <p:val>
-                                            <p:strVal val="#ppt_x-0.05"/>
-                                          </p:val>
-                                        </p:tav>
-                                      </p:tavLst>
-                                    </p:anim>
-                                    <p:anim calcmode="lin" valueType="num">
-                                      <p:cBhvr>
-                                        <p:cTn id="37" dur="400" decel="100000" fill="hold"/>
-                                        <p:tgtEl>
-                                          <p:spTgt spid="6"/>
-                                        </p:tgtEl>
-                                        <p:attrNameLst>
-                                          <p:attrName>ppt_y</p:attrName>
-                                        </p:attrNameLst>
-                                      </p:cBhvr>
-                                      <p:tavLst>
-                                        <p:tav tm="0">
-                                          <p:val>
-                                            <p:strVal val="#ppt_y-0.4"/>
-                                          </p:val>
-                                        </p:tav>
-                                        <p:tav tm="100000">
-                                          <p:val>
-                                            <p:strVal val="#ppt_y+0.1"/>
-                                          </p:val>
-                                        </p:tav>
-                                      </p:tavLst>
-                                    </p:anim>
-                                    <p:anim calcmode="lin" valueType="num">
-                                      <p:cBhvr>
-                                        <p:cTn id="38" dur="100" accel="100000" fill="hold">
-                                          <p:stCondLst>
-                                            <p:cond delay="400"/>
-                                          </p:stCondLst>
-                                        </p:cTn>
-                                        <p:tgtEl>
-                                          <p:spTgt spid="6"/>
-                                        </p:tgtEl>
-                                        <p:attrNameLst>
-                                          <p:attrName>ppt_x</p:attrName>
-                                        </p:attrNameLst>
-                                      </p:cBhvr>
-                                      <p:tavLst>
-                                        <p:tav tm="0">
-                                          <p:val>
-                                            <p:strVal val="#ppt_x-0.05"/>
-                                          </p:val>
-                                        </p:tav>
-                                        <p:tav tm="100000">
-                                          <p:val>
-                                            <p:strVal val="#ppt_x"/>
-                                          </p:val>
-                                        </p:tav>
-                                      </p:tavLst>
-                                    </p:anim>
-                                    <p:anim calcmode="lin" valueType="num">
-                                      <p:cBhvr>
-                                        <p:cTn id="39" dur="100" accel="100000" fill="hold">
-                                          <p:stCondLst>
-                                            <p:cond delay="400"/>
-                                          </p:stCondLst>
-                                        </p:cTn>
-                                        <p:tgtEl>
-                                          <p:spTgt spid="6"/>
-                                        </p:tgtEl>
-                                        <p:attrNameLst>
-                                          <p:attrName>ppt_y</p:attrName>
-                                        </p:attrNameLst>
-                                      </p:cBhvr>
-                                      <p:tavLst>
-                                        <p:tav tm="0">
-                                          <p:val>
-                                            <p:strVal val="#ppt_y+0.1"/>
-                                          </p:val>
-                                        </p:tav>
-                                        <p:tav tm="100000">
-                                          <p:val>
-                                            <p:strVal val="#ppt_y"/>
-                                          </p:val>
-                                        </p:tav>
-                                      </p:tavLst>
-                                    </p:anim>
-                                  </p:childTnLst>
-                                </p:cTn>
-                              </p:par>
-                            </p:childTnLst>
-                          </p:cTn>
-                        </p:par>
-                        <p:par>
-                          <p:cTn id="40" fill="hold">
-                            <p:stCondLst>
-                              <p:cond delay="2240"/>
-                            </p:stCondLst>
-                            <p:childTnLst>
-                              <p:par>
-                                <p:cTn id="41" presetID="30" presetClass="entr" presetSubtype="0" fill="hold" grpId="0" nodeType="afterEffect">
-                                  <p:stCondLst>
-                                    <p:cond delay="160"/>
-                                  </p:stCondLst>
-                                  <p:childTnLst>
-                                    <p:set>
-                                      <p:cBhvr>
-                                        <p:cTn id="42" dur="1" fill="hold">
-                                          <p:stCondLst>
-                                            <p:cond delay="0"/>
-                                          </p:stCondLst>
-                                        </p:cTn>
-                                        <p:tgtEl>
-                                          <p:spTgt spid="7"/>
-                                        </p:tgtEl>
-                                        <p:attrNameLst>
-                                          <p:attrName>style.visibility</p:attrName>
-                                        </p:attrNameLst>
-                                      </p:cBhvr>
-                                      <p:to>
-                                        <p:strVal val="visible"/>
-                                      </p:to>
-                                    </p:set>
-                                    <p:animEffect transition="in" filter="fade">
-                                      <p:cBhvr>
-                                        <p:cTn id="43" dur="400" decel="100000"/>
-                                        <p:tgtEl>
-                                          <p:spTgt spid="7"/>
-                                        </p:tgtEl>
-                                      </p:cBhvr>
-                                    </p:animEffect>
-                                    <p:anim calcmode="lin" valueType="num">
-                                      <p:cBhvr>
-                                        <p:cTn id="44" dur="400" decel="100000" fill="hold"/>
-                                        <p:tgtEl>
-                                          <p:spTgt spid="7"/>
-                                        </p:tgtEl>
-                                        <p:attrNameLst>
-                                          <p:attrName>style.rotation</p:attrName>
-                                        </p:attrNameLst>
-                                      </p:cBhvr>
-                                      <p:tavLst>
-                                        <p:tav tm="0">
-                                          <p:val>
-                                            <p:fltVal val="-90"/>
-                                          </p:val>
-                                        </p:tav>
-                                        <p:tav tm="100000">
-                                          <p:val>
-                                            <p:fltVal val="0"/>
-                                          </p:val>
-                                        </p:tav>
-                                      </p:tavLst>
-                                    </p:anim>
-                                    <p:anim calcmode="lin" valueType="num">
-                                      <p:cBhvr>
-                                        <p:cTn id="45" dur="400" decel="100000" fill="hold"/>
-                                        <p:tgtEl>
-                                          <p:spTgt spid="7"/>
-                                        </p:tgtEl>
-                                        <p:attrNameLst>
-                                          <p:attrName>ppt_x</p:attrName>
-                                        </p:attrNameLst>
-                                      </p:cBhvr>
-                                      <p:tavLst>
-                                        <p:tav tm="0">
-                                          <p:val>
-                                            <p:strVal val="#ppt_x+0.4"/>
-                                          </p:val>
-                                        </p:tav>
-                                        <p:tav tm="100000">
-                                          <p:val>
-                                            <p:strVal val="#ppt_x-0.05"/>
-                                          </p:val>
-                                        </p:tav>
-                                      </p:tavLst>
-                                    </p:anim>
-                                    <p:anim calcmode="lin" valueType="num">
-                                      <p:cBhvr>
-                                        <p:cTn id="46" dur="400" decel="100000" fill="hold"/>
-                                        <p:tgtEl>
-                                          <p:spTgt spid="7"/>
-                                        </p:tgtEl>
-                                        <p:attrNameLst>
-                                          <p:attrName>ppt_y</p:attrName>
-                                        </p:attrNameLst>
-                                      </p:cBhvr>
-                                      <p:tavLst>
-                                        <p:tav tm="0">
-                                          <p:val>
-                                            <p:strVal val="#ppt_y-0.4"/>
-                                          </p:val>
-                                        </p:tav>
-                                        <p:tav tm="100000">
-                                          <p:val>
-                                            <p:strVal val="#ppt_y+0.1"/>
-                                          </p:val>
-                                        </p:tav>
-                                      </p:tavLst>
-                                    </p:anim>
-                                    <p:anim calcmode="lin" valueType="num">
-                                      <p:cBhvr>
-                                        <p:cTn id="47" dur="100" accel="100000" fill="hold">
-                                          <p:stCondLst>
-                                            <p:cond delay="400"/>
-                                          </p:stCondLst>
-                                        </p:cTn>
-                                        <p:tgtEl>
-                                          <p:spTgt spid="7"/>
-                                        </p:tgtEl>
-                                        <p:attrNameLst>
-                                          <p:attrName>ppt_x</p:attrName>
-                                        </p:attrNameLst>
-                                      </p:cBhvr>
-                                      <p:tavLst>
-                                        <p:tav tm="0">
-                                          <p:val>
-                                            <p:strVal val="#ppt_x-0.05"/>
-                                          </p:val>
-                                        </p:tav>
-                                        <p:tav tm="100000">
-                                          <p:val>
-                                            <p:strVal val="#ppt_x"/>
-                                          </p:val>
-                                        </p:tav>
-                                      </p:tavLst>
-                                    </p:anim>
-                                    <p:anim calcmode="lin" valueType="num">
-                                      <p:cBhvr>
-                                        <p:cTn id="48" dur="100" accel="100000" fill="hold">
-                                          <p:stCondLst>
-                                            <p:cond delay="400"/>
-                                          </p:stCondLst>
-                                        </p:cTn>
-                                        <p:tgtEl>
-                                          <p:spTgt spid="7"/>
-                                        </p:tgtEl>
-                                        <p:attrNameLst>
-                                          <p:attrName>ppt_y</p:attrName>
-                                        </p:attrNameLst>
-                                      </p:cBhvr>
-                                      <p:tavLst>
-                                        <p:tav tm="0">
-                                          <p:val>
-                                            <p:strVal val="#ppt_y+0.1"/>
-                                          </p:val>
-                                        </p:tav>
-                                        <p:tav tm="100000">
-                                          <p:val>
-                                            <p:strVal val="#ppt_y"/>
-                                          </p:val>
-                                        </p:tav>
-                                      </p:tavLst>
-                                    </p:anim>
-                                  </p:childTnLst>
-                                </p:cTn>
-                              </p:par>
-                            </p:childTnLst>
-                          </p:cTn>
-                        </p:par>
-                        <p:par>
-                          <p:cTn id="49" fill="hold">
-                            <p:stCondLst>
-                              <p:cond delay="2900"/>
-                            </p:stCondLst>
-                            <p:childTnLst>
-                              <p:par>
-                                <p:cTn id="50" presetID="30" presetClass="entr" presetSubtype="0" fill="hold" grpId="0" nodeType="afterEffect">
-                                  <p:stCondLst>
-                                    <p:cond delay="200"/>
-                                  </p:stCondLst>
-                                  <p:childTnLst>
-                                    <p:set>
-                                      <p:cBhvr>
-                                        <p:cTn id="51" dur="1" fill="hold">
-                                          <p:stCondLst>
-                                            <p:cond delay="0"/>
-                                          </p:stCondLst>
-                                        </p:cTn>
-                                        <p:tgtEl>
-                                          <p:spTgt spid="8"/>
-                                        </p:tgtEl>
-                                        <p:attrNameLst>
-                                          <p:attrName>style.visibility</p:attrName>
-                                        </p:attrNameLst>
-                                      </p:cBhvr>
-                                      <p:to>
-                                        <p:strVal val="visible"/>
-                                      </p:to>
-                                    </p:set>
-                                    <p:animEffect transition="in" filter="fade">
-                                      <p:cBhvr>
-                                        <p:cTn id="52" dur="400" decel="100000"/>
-                                        <p:tgtEl>
-                                          <p:spTgt spid="8"/>
-                                        </p:tgtEl>
-                                      </p:cBhvr>
-                                    </p:animEffect>
-                                    <p:anim calcmode="lin" valueType="num">
-                                      <p:cBhvr>
-                                        <p:cTn id="53" dur="400" decel="100000" fill="hold"/>
-                                        <p:tgtEl>
-                                          <p:spTgt spid="8"/>
-                                        </p:tgtEl>
-                                        <p:attrNameLst>
-                                          <p:attrName>style.rotation</p:attrName>
-                                        </p:attrNameLst>
-                                      </p:cBhvr>
-                                      <p:tavLst>
-                                        <p:tav tm="0">
-                                          <p:val>
-                                            <p:fltVal val="-90"/>
-                                          </p:val>
-                                        </p:tav>
-                                        <p:tav tm="100000">
-                                          <p:val>
-                                            <p:fltVal val="0"/>
-                                          </p:val>
-                                        </p:tav>
-                                      </p:tavLst>
-                                    </p:anim>
-                                    <p:anim calcmode="lin" valueType="num">
-                                      <p:cBhvr>
-                                        <p:cTn id="54" dur="400" decel="100000" fill="hold"/>
-                                        <p:tgtEl>
-                                          <p:spTgt spid="8"/>
-                                        </p:tgtEl>
-                                        <p:attrNameLst>
-                                          <p:attrName>ppt_x</p:attrName>
-                                        </p:attrNameLst>
-                                      </p:cBhvr>
-                                      <p:tavLst>
-                                        <p:tav tm="0">
-                                          <p:val>
-                                            <p:strVal val="#ppt_x+0.4"/>
-                                          </p:val>
-                                        </p:tav>
-                                        <p:tav tm="100000">
-                                          <p:val>
-                                            <p:strVal val="#ppt_x-0.05"/>
-                                          </p:val>
-                                        </p:tav>
-                                      </p:tavLst>
-                                    </p:anim>
-                                    <p:anim calcmode="lin" valueType="num">
-                                      <p:cBhvr>
-                                        <p:cTn id="55" dur="400" decel="100000" fill="hold"/>
-                                        <p:tgtEl>
-                                          <p:spTgt spid="8"/>
-                                        </p:tgtEl>
-                                        <p:attrNameLst>
-                                          <p:attrName>ppt_y</p:attrName>
-                                        </p:attrNameLst>
-                                      </p:cBhvr>
-                                      <p:tavLst>
-                                        <p:tav tm="0">
-                                          <p:val>
-                                            <p:strVal val="#ppt_y-0.4"/>
-                                          </p:val>
-                                        </p:tav>
-                                        <p:tav tm="100000">
-                                          <p:val>
-                                            <p:strVal val="#ppt_y+0.1"/>
-                                          </p:val>
-                                        </p:tav>
-                                      </p:tavLst>
-                                    </p:anim>
-                                    <p:anim calcmode="lin" valueType="num">
-                                      <p:cBhvr>
-                                        <p:cTn id="56" dur="100" accel="100000" fill="hold">
-                                          <p:stCondLst>
-                                            <p:cond delay="400"/>
-                                          </p:stCondLst>
-                                        </p:cTn>
-                                        <p:tgtEl>
-                                          <p:spTgt spid="8"/>
-                                        </p:tgtEl>
-                                        <p:attrNameLst>
-                                          <p:attrName>ppt_x</p:attrName>
-                                        </p:attrNameLst>
-                                      </p:cBhvr>
-                                      <p:tavLst>
-                                        <p:tav tm="0">
-                                          <p:val>
-                                            <p:strVal val="#ppt_x-0.05"/>
-                                          </p:val>
-                                        </p:tav>
-                                        <p:tav tm="100000">
-                                          <p:val>
-                                            <p:strVal val="#ppt_x"/>
-                                          </p:val>
-                                        </p:tav>
-                                      </p:tavLst>
-                                    </p:anim>
-                                    <p:anim calcmode="lin" valueType="num">
-                                      <p:cBhvr>
-                                        <p:cTn id="57" dur="100" accel="100000" fill="hold">
-                                          <p:stCondLst>
-                                            <p:cond delay="400"/>
-                                          </p:stCondLst>
-                                        </p:cTn>
-                                        <p:tgtEl>
-                                          <p:spTgt spid="8"/>
-                                        </p:tgtEl>
-                                        <p:attrNameLst>
-                                          <p:attrName>ppt_y</p:attrName>
-                                        </p:attrNameLst>
-                                      </p:cBhvr>
-                                      <p:tavLst>
-                                        <p:tav tm="0">
-                                          <p:val>
-                                            <p:strVal val="#ppt_y+0.1"/>
-                                          </p:val>
-                                        </p:tav>
-                                        <p:tav tm="100000">
-                                          <p:val>
-                                            <p:strVal val="#ppt_y"/>
-                                          </p:val>
-                                        </p:tav>
-                                      </p:tavLst>
-                                    </p:anim>
-                                  </p:childTnLst>
-                                </p:cTn>
-                              </p:par>
-                            </p:childTnLst>
-                          </p:cTn>
-                        </p:par>
-                      </p:childTnLst>
-                    </p:cTn>
-                  </p:par>
-                </p:childTnLst>
-              </p:cTn>
-              <p:prevCondLst>
-                <p:cond evt="onPrev" delay="0">
-                  <p:tgtEl>
-                    <p:sldTgt/>
-                  </p:tgtEl>
-                </p:cond>
-              </p:prevCondLst>
-              <p:nextCondLst>
-                <p:cond evt="onNext" delay="0">
-                  <p:tgtEl>
-                    <p:sldTgt/>
-                  </p:tgtEl>
-                </p:cond>
-              </p:nextCondLst>
-            </p:seq>
-          </p:childTnLst>
-        </p:cTn>
-      </p:par>
-    </p:tnLst>
-    <p:bldLst>
-      <p:bldP spid="3" grpId="0" animBg="1"/>
-      <p:bldP spid="4" grpId="0" animBg="1"/>
-      <p:bldP spid="5" grpId="0"/>
-      <p:bldP spid="6" grpId="0" animBg="1"/>
-      <p:bldP spid="7" grpId="0"/>
-      <p:bldP spid="8" grpId="0"/>
-    </p:bldLst>
-  </p:timing>
 </p:sld>
 </file>
 
@@ -4675,7 +3620,7 @@
               </a:spcAft>
             </a:pPr>
             <a:r>
-              <a:rPr sz="3100" b="0">
+              <a:rPr sz="3100" b="0" dirty="0">
                 <a:solidFill>
                   <a:srgbClr val="F4F0FB"/>
                 </a:solidFill>
@@ -4845,7 +3790,7 @@
               </a:spcAft>
             </a:pPr>
             <a:r>
-              <a:rPr sz="1200" b="1">
+              <a:rPr sz="1200" b="1" dirty="0">
                 <a:solidFill>
                   <a:srgbClr val="9E93B5"/>
                 </a:solidFill>
@@ -4861,7 +3806,7 @@
               </a:spcAft>
             </a:pPr>
             <a:r>
-              <a:rPr sz="2200" b="1">
+              <a:rPr sz="2200" b="1" dirty="0">
                 <a:solidFill>
                   <a:srgbClr val="BB92FF"/>
                 </a:solidFill>
@@ -4877,7 +3822,7 @@
               </a:spcAft>
             </a:pPr>
             <a:r>
-              <a:rPr sz="2700" b="1">
+              <a:rPr sz="2700" b="1" dirty="0">
                 <a:solidFill>
                   <a:srgbClr val="F4F0FB"/>
                 </a:solidFill>
@@ -4893,7 +3838,7 @@
               </a:spcAft>
             </a:pPr>
             <a:r>
-              <a:rPr sz="1200" b="0">
+              <a:rPr sz="1200" b="0" dirty="0">
                 <a:solidFill>
                   <a:srgbClr val="9E93B5"/>
                 </a:solidFill>
@@ -4908,7 +3853,7 @@
                 <a:spcPts val="600"/>
               </a:spcAft>
             </a:pPr>
-            <a:endParaRPr sz="1200" b="0">
+            <a:endParaRPr sz="1200" b="0" dirty="0">
               <a:solidFill>
                 <a:srgbClr val="9E93B5"/>
               </a:solidFill>
@@ -4922,13 +3867,49 @@
               </a:spcAft>
             </a:pPr>
             <a:r>
-              <a:rPr sz="1250" b="0">
+              <a:rPr sz="1250" b="0" dirty="0">
                 <a:solidFill>
                   <a:srgbClr val="9E93B5"/>
                 </a:solidFill>
                 <a:latin typeface="Segoe UI"/>
               </a:rPr>
-              <a:t>Lager und Alltag im Griff.</a:t>
+              <a:t>Lager und </a:t>
+            </a:r>
+            <a:r>
+              <a:rPr sz="1250" b="0" dirty="0" err="1">
+                <a:solidFill>
+                  <a:srgbClr val="9E93B5"/>
+                </a:solidFill>
+                <a:latin typeface="Segoe UI"/>
+              </a:rPr>
+              <a:t>Alltag</a:t>
+            </a:r>
+            <a:r>
+              <a:rPr sz="1250" b="0" dirty="0">
+                <a:solidFill>
+                  <a:srgbClr val="9E93B5"/>
+                </a:solidFill>
+                <a:latin typeface="Segoe UI"/>
+              </a:rPr>
+              <a:t> </a:t>
+            </a:r>
+            <a:r>
+              <a:rPr sz="1250" b="0" dirty="0" err="1">
+                <a:solidFill>
+                  <a:srgbClr val="9E93B5"/>
+                </a:solidFill>
+                <a:latin typeface="Segoe UI"/>
+              </a:rPr>
+              <a:t>im</a:t>
+            </a:r>
+            <a:r>
+              <a:rPr sz="1250" b="0" dirty="0">
+                <a:solidFill>
+                  <a:srgbClr val="9E93B5"/>
+                </a:solidFill>
+                <a:latin typeface="Segoe UI"/>
+              </a:rPr>
+              <a:t> Griff.</a:t>
             </a:r>
           </a:p>
         </p:txBody>
@@ -5016,7 +3997,7 @@
               </a:spcAft>
             </a:pPr>
             <a:r>
-              <a:rPr sz="1200" b="1">
+              <a:rPr sz="1200" b="1" dirty="0">
                 <a:solidFill>
                   <a:srgbClr val="EADFFB"/>
                 </a:solidFill>
@@ -5032,7 +4013,7 @@
               </a:spcAft>
             </a:pPr>
             <a:r>
-              <a:rPr sz="2200" b="1">
+              <a:rPr sz="2200" b="1" dirty="0">
                 <a:solidFill>
                   <a:srgbClr val="FFFFFF"/>
                 </a:solidFill>
@@ -5048,7 +4029,7 @@
               </a:spcAft>
             </a:pPr>
             <a:r>
-              <a:rPr sz="2700" b="1">
+              <a:rPr sz="2700" b="1" dirty="0">
                 <a:solidFill>
                   <a:srgbClr val="FFFFFF"/>
                 </a:solidFill>
@@ -5064,7 +4045,7 @@
               </a:spcAft>
             </a:pPr>
             <a:r>
-              <a:rPr sz="1200" b="0">
+              <a:rPr sz="1200" b="0" dirty="0">
                 <a:solidFill>
                   <a:srgbClr val="EADFFB"/>
                 </a:solidFill>
@@ -5079,7 +4060,7 @@
                 <a:spcPts val="600"/>
               </a:spcAft>
             </a:pPr>
-            <a:endParaRPr sz="1200" b="0">
+            <a:endParaRPr sz="1200" b="0" dirty="0">
               <a:solidFill>
                 <a:srgbClr val="EADFFB"/>
               </a:solidFill>
@@ -5093,13 +4074,85 @@
               </a:spcAft>
             </a:pPr>
             <a:r>
-              <a:rPr sz="1250" b="0">
+              <a:rPr sz="1250" b="0" dirty="0">
                 <a:solidFill>
                   <a:srgbClr val="EADFFB"/>
                 </a:solidFill>
                 <a:latin typeface="Segoe UI"/>
               </a:rPr>
-              <a:t>Dazu: dein Shop verkauft aktiv mit.</a:t>
+              <a:t>Dazu: </a:t>
+            </a:r>
+            <a:r>
+              <a:rPr sz="1250" b="0" dirty="0" err="1">
+                <a:solidFill>
+                  <a:srgbClr val="EADFFB"/>
+                </a:solidFill>
+                <a:latin typeface="Segoe UI"/>
+              </a:rPr>
+              <a:t>dein</a:t>
+            </a:r>
+            <a:r>
+              <a:rPr sz="1250" b="0" dirty="0">
+                <a:solidFill>
+                  <a:srgbClr val="EADFFB"/>
+                </a:solidFill>
+                <a:latin typeface="Segoe UI"/>
+              </a:rPr>
+              <a:t> Shop </a:t>
+            </a:r>
+            <a:r>
+              <a:rPr sz="1250" b="0" dirty="0" err="1">
+                <a:solidFill>
+                  <a:srgbClr val="EADFFB"/>
+                </a:solidFill>
+                <a:latin typeface="Segoe UI"/>
+              </a:rPr>
+              <a:t>verkauft</a:t>
+            </a:r>
+            <a:r>
+              <a:rPr sz="1250" b="0" dirty="0">
+                <a:solidFill>
+                  <a:srgbClr val="EADFFB"/>
+                </a:solidFill>
+                <a:latin typeface="Segoe UI"/>
+              </a:rPr>
+              <a:t> </a:t>
+            </a:r>
+            <a:r>
+              <a:rPr sz="1250" b="0" dirty="0" err="1">
+                <a:solidFill>
+                  <a:srgbClr val="EADFFB"/>
+                </a:solidFill>
+                <a:latin typeface="Segoe UI"/>
+              </a:rPr>
+              <a:t>aktiv</a:t>
+            </a:r>
+            <a:r>
+              <a:rPr sz="1250" b="0" dirty="0">
+                <a:solidFill>
+                  <a:srgbClr val="EADFFB"/>
+                </a:solidFill>
+                <a:latin typeface="Segoe UI"/>
+              </a:rPr>
+              <a:t> </a:t>
+            </a:r>
+            <a:r>
+              <a:rPr sz="1250" b="0" dirty="0" err="1">
+                <a:solidFill>
+                  <a:srgbClr val="EADFFB"/>
+                </a:solidFill>
+                <a:latin typeface="Segoe UI"/>
+              </a:rPr>
+              <a:t>mit</a:t>
+            </a:r>
+            <a:r>
+              <a:rPr sz="1250" b="0" dirty="0">
+                <a:solidFill>
+                  <a:srgbClr val="EADFFB"/>
+                </a:solidFill>
+                <a:latin typeface="Segoe UI"/>
+              </a:rPr>
+              <a:t>.</a:t>
             </a:r>
           </a:p>
         </p:txBody>
@@ -5187,14 +4240,29 @@
               </a:spcAft>
             </a:pPr>
             <a:r>
-              <a:rPr sz="1150" b="1">
+              <a:rPr sz="1150" b="1" dirty="0">
                 <a:solidFill>
                   <a:srgbClr val="FFFFFF"/>
                 </a:solidFill>
                 <a:latin typeface="Segoe UI Semibold"/>
               </a:rPr>
-              <a:t>Unser Vorschlag</a:t>
-            </a:r>
+              <a:t>Unser </a:t>
+            </a:r>
+            <a:r>
+              <a:rPr sz="1150" b="1" dirty="0" err="1">
+                <a:solidFill>
+                  <a:srgbClr val="FFFFFF"/>
+                </a:solidFill>
+                <a:latin typeface="Segoe UI Semibold"/>
+              </a:rPr>
+              <a:t>Vorschlag</a:t>
+            </a:r>
+            <a:endParaRPr sz="1150" b="1" dirty="0">
+              <a:solidFill>
+                <a:srgbClr val="FFFFFF"/>
+              </a:solidFill>
+              <a:latin typeface="Segoe UI Semibold"/>
+            </a:endParaRPr>
           </a:p>
         </p:txBody>
       </p:sp>
@@ -5460,2414 +4528,18 @@
   <p:clrMapOvr>
     <a:masterClrMapping/>
   </p:clrMapOvr>
-  <mc:AlternateContent xmlns:mc="http://schemas.openxmlformats.org/markup-compatibility/2006">
-    <mc:Choice xmlns:p14="http://schemas.microsoft.com/office/powerpoint/2010/main" Requires="p14">
+  <mc:AlternateContent xmlns:mc="http://schemas.openxmlformats.org/markup-compatibility/2006" xmlns:p14="http://schemas.microsoft.com/office/powerpoint/2010/main">
+    <mc:Choice Requires="p14">
       <p:transition spd="med" p14:dur="700">
         <p14:reveal/>
       </p:transition>
     </mc:Choice>
-    <mc:Fallback>
+    <mc:Fallback xmlns="">
       <p:transition spd="med">
         <p:fade/>
       </p:transition>
     </mc:Fallback>
   </mc:AlternateContent>
-  <p:timing>
-    <p:tnLst>
-      <p:par>
-        <p:cTn id="1" dur="indefinite" restart="never" nodeType="tmRoot">
-          <p:childTnLst>
-            <p:seq concurrent="1" nextAc="seek">
-              <p:cTn id="2" dur="indefinite" nodeType="mainSeq">
-                <p:childTnLst>
-                  <p:par>
-                    <p:cTn id="3" fill="hold">
-                      <p:stCondLst>
-                        <p:cond delay="indefinite"/>
-                        <p:cond evt="onBegin" delay="0">
-                          <p:tn val="2"/>
-                        </p:cond>
-                      </p:stCondLst>
-                      <p:childTnLst>
-                        <p:par>
-                          <p:cTn id="4" fill="hold">
-                            <p:stCondLst>
-                              <p:cond delay="0"/>
-                            </p:stCondLst>
-                            <p:childTnLst>
-                              <p:par>
-                                <p:cTn id="5" presetID="30" presetClass="entr" presetSubtype="0" fill="hold" grpId="0" nodeType="withEffect">
-                                  <p:stCondLst>
-                                    <p:cond delay="0"/>
-                                  </p:stCondLst>
-                                  <p:childTnLst>
-                                    <p:set>
-                                      <p:cBhvr>
-                                        <p:cTn id="6" dur="1" fill="hold">
-                                          <p:stCondLst>
-                                            <p:cond delay="0"/>
-                                          </p:stCondLst>
-                                        </p:cTn>
-                                        <p:tgtEl>
-                                          <p:spTgt spid="3"/>
-                                        </p:tgtEl>
-                                        <p:attrNameLst>
-                                          <p:attrName>style.visibility</p:attrName>
-                                        </p:attrNameLst>
-                                      </p:cBhvr>
-                                      <p:to>
-                                        <p:strVal val="visible"/>
-                                      </p:to>
-                                    </p:set>
-                                    <p:animEffect transition="in" filter="fade">
-                                      <p:cBhvr>
-                                        <p:cTn id="7" dur="400" decel="100000"/>
-                                        <p:tgtEl>
-                                          <p:spTgt spid="3"/>
-                                        </p:tgtEl>
-                                      </p:cBhvr>
-                                    </p:animEffect>
-                                    <p:anim calcmode="lin" valueType="num">
-                                      <p:cBhvr>
-                                        <p:cTn id="8" dur="400" decel="100000" fill="hold"/>
-                                        <p:tgtEl>
-                                          <p:spTgt spid="3"/>
-                                        </p:tgtEl>
-                                        <p:attrNameLst>
-                                          <p:attrName>style.rotation</p:attrName>
-                                        </p:attrNameLst>
-                                      </p:cBhvr>
-                                      <p:tavLst>
-                                        <p:tav tm="0">
-                                          <p:val>
-                                            <p:fltVal val="-90"/>
-                                          </p:val>
-                                        </p:tav>
-                                        <p:tav tm="100000">
-                                          <p:val>
-                                            <p:fltVal val="0"/>
-                                          </p:val>
-                                        </p:tav>
-                                      </p:tavLst>
-                                    </p:anim>
-                                    <p:anim calcmode="lin" valueType="num">
-                                      <p:cBhvr>
-                                        <p:cTn id="9" dur="400" decel="100000" fill="hold"/>
-                                        <p:tgtEl>
-                                          <p:spTgt spid="3"/>
-                                        </p:tgtEl>
-                                        <p:attrNameLst>
-                                          <p:attrName>ppt_x</p:attrName>
-                                        </p:attrNameLst>
-                                      </p:cBhvr>
-                                      <p:tavLst>
-                                        <p:tav tm="0">
-                                          <p:val>
-                                            <p:strVal val="#ppt_x+0.4"/>
-                                          </p:val>
-                                        </p:tav>
-                                        <p:tav tm="100000">
-                                          <p:val>
-                                            <p:strVal val="#ppt_x-0.05"/>
-                                          </p:val>
-                                        </p:tav>
-                                      </p:tavLst>
-                                    </p:anim>
-                                    <p:anim calcmode="lin" valueType="num">
-                                      <p:cBhvr>
-                                        <p:cTn id="10" dur="400" decel="100000" fill="hold"/>
-                                        <p:tgtEl>
-                                          <p:spTgt spid="3"/>
-                                        </p:tgtEl>
-                                        <p:attrNameLst>
-                                          <p:attrName>ppt_y</p:attrName>
-                                        </p:attrNameLst>
-                                      </p:cBhvr>
-                                      <p:tavLst>
-                                        <p:tav tm="0">
-                                          <p:val>
-                                            <p:strVal val="#ppt_y-0.4"/>
-                                          </p:val>
-                                        </p:tav>
-                                        <p:tav tm="100000">
-                                          <p:val>
-                                            <p:strVal val="#ppt_y+0.1"/>
-                                          </p:val>
-                                        </p:tav>
-                                      </p:tavLst>
-                                    </p:anim>
-                                    <p:anim calcmode="lin" valueType="num">
-                                      <p:cBhvr>
-                                        <p:cTn id="11" dur="100" accel="100000" fill="hold">
-                                          <p:stCondLst>
-                                            <p:cond delay="400"/>
-                                          </p:stCondLst>
-                                        </p:cTn>
-                                        <p:tgtEl>
-                                          <p:spTgt spid="3"/>
-                                        </p:tgtEl>
-                                        <p:attrNameLst>
-                                          <p:attrName>ppt_x</p:attrName>
-                                        </p:attrNameLst>
-                                      </p:cBhvr>
-                                      <p:tavLst>
-                                        <p:tav tm="0">
-                                          <p:val>
-                                            <p:strVal val="#ppt_x-0.05"/>
-                                          </p:val>
-                                        </p:tav>
-                                        <p:tav tm="100000">
-                                          <p:val>
-                                            <p:strVal val="#ppt_x"/>
-                                          </p:val>
-                                        </p:tav>
-                                      </p:tavLst>
-                                    </p:anim>
-                                    <p:anim calcmode="lin" valueType="num">
-                                      <p:cBhvr>
-                                        <p:cTn id="12" dur="100" accel="100000" fill="hold">
-                                          <p:stCondLst>
-                                            <p:cond delay="400"/>
-                                          </p:stCondLst>
-                                        </p:cTn>
-                                        <p:tgtEl>
-                                          <p:spTgt spid="3"/>
-                                        </p:tgtEl>
-                                        <p:attrNameLst>
-                                          <p:attrName>ppt_y</p:attrName>
-                                        </p:attrNameLst>
-                                      </p:cBhvr>
-                                      <p:tavLst>
-                                        <p:tav tm="0">
-                                          <p:val>
-                                            <p:strVal val="#ppt_y+0.1"/>
-                                          </p:val>
-                                        </p:tav>
-                                        <p:tav tm="100000">
-                                          <p:val>
-                                            <p:strVal val="#ppt_y"/>
-                                          </p:val>
-                                        </p:tav>
-                                      </p:tavLst>
-                                    </p:anim>
-                                  </p:childTnLst>
-                                </p:cTn>
-                              </p:par>
-                            </p:childTnLst>
-                          </p:cTn>
-                        </p:par>
-                        <p:par>
-                          <p:cTn id="13" fill="hold">
-                            <p:stCondLst>
-                              <p:cond delay="500"/>
-                            </p:stCondLst>
-                            <p:childTnLst>
-                              <p:par>
-                                <p:cTn id="14" presetID="30" presetClass="entr" presetSubtype="0" fill="hold" grpId="0" nodeType="afterEffect">
-                                  <p:stCondLst>
-                                    <p:cond delay="40"/>
-                                  </p:stCondLst>
-                                  <p:childTnLst>
-                                    <p:set>
-                                      <p:cBhvr>
-                                        <p:cTn id="15" dur="1" fill="hold">
-                                          <p:stCondLst>
-                                            <p:cond delay="0"/>
-                                          </p:stCondLst>
-                                        </p:cTn>
-                                        <p:tgtEl>
-                                          <p:spTgt spid="4"/>
-                                        </p:tgtEl>
-                                        <p:attrNameLst>
-                                          <p:attrName>style.visibility</p:attrName>
-                                        </p:attrNameLst>
-                                      </p:cBhvr>
-                                      <p:to>
-                                        <p:strVal val="visible"/>
-                                      </p:to>
-                                    </p:set>
-                                    <p:animEffect transition="in" filter="fade">
-                                      <p:cBhvr>
-                                        <p:cTn id="16" dur="400" decel="100000"/>
-                                        <p:tgtEl>
-                                          <p:spTgt spid="4"/>
-                                        </p:tgtEl>
-                                      </p:cBhvr>
-                                    </p:animEffect>
-                                    <p:anim calcmode="lin" valueType="num">
-                                      <p:cBhvr>
-                                        <p:cTn id="17" dur="400" decel="100000" fill="hold"/>
-                                        <p:tgtEl>
-                                          <p:spTgt spid="4"/>
-                                        </p:tgtEl>
-                                        <p:attrNameLst>
-                                          <p:attrName>style.rotation</p:attrName>
-                                        </p:attrNameLst>
-                                      </p:cBhvr>
-                                      <p:tavLst>
-                                        <p:tav tm="0">
-                                          <p:val>
-                                            <p:fltVal val="-90"/>
-                                          </p:val>
-                                        </p:tav>
-                                        <p:tav tm="100000">
-                                          <p:val>
-                                            <p:fltVal val="0"/>
-                                          </p:val>
-                                        </p:tav>
-                                      </p:tavLst>
-                                    </p:anim>
-                                    <p:anim calcmode="lin" valueType="num">
-                                      <p:cBhvr>
-                                        <p:cTn id="18" dur="400" decel="100000" fill="hold"/>
-                                        <p:tgtEl>
-                                          <p:spTgt spid="4"/>
-                                        </p:tgtEl>
-                                        <p:attrNameLst>
-                                          <p:attrName>ppt_x</p:attrName>
-                                        </p:attrNameLst>
-                                      </p:cBhvr>
-                                      <p:tavLst>
-                                        <p:tav tm="0">
-                                          <p:val>
-                                            <p:strVal val="#ppt_x+0.4"/>
-                                          </p:val>
-                                        </p:tav>
-                                        <p:tav tm="100000">
-                                          <p:val>
-                                            <p:strVal val="#ppt_x-0.05"/>
-                                          </p:val>
-                                        </p:tav>
-                                      </p:tavLst>
-                                    </p:anim>
-                                    <p:anim calcmode="lin" valueType="num">
-                                      <p:cBhvr>
-                                        <p:cTn id="19" dur="400" decel="100000" fill="hold"/>
-                                        <p:tgtEl>
-                                          <p:spTgt spid="4"/>
-                                        </p:tgtEl>
-                                        <p:attrNameLst>
-                                          <p:attrName>ppt_y</p:attrName>
-                                        </p:attrNameLst>
-                                      </p:cBhvr>
-                                      <p:tavLst>
-                                        <p:tav tm="0">
-                                          <p:val>
-                                            <p:strVal val="#ppt_y-0.4"/>
-                                          </p:val>
-                                        </p:tav>
-                                        <p:tav tm="100000">
-                                          <p:val>
-                                            <p:strVal val="#ppt_y+0.1"/>
-                                          </p:val>
-                                        </p:tav>
-                                      </p:tavLst>
-                                    </p:anim>
-                                    <p:anim calcmode="lin" valueType="num">
-                                      <p:cBhvr>
-                                        <p:cTn id="20" dur="100" accel="100000" fill="hold">
-                                          <p:stCondLst>
-                                            <p:cond delay="400"/>
-                                          </p:stCondLst>
-                                        </p:cTn>
-                                        <p:tgtEl>
-                                          <p:spTgt spid="4"/>
-                                        </p:tgtEl>
-                                        <p:attrNameLst>
-                                          <p:attrName>ppt_x</p:attrName>
-                                        </p:attrNameLst>
-                                      </p:cBhvr>
-                                      <p:tavLst>
-                                        <p:tav tm="0">
-                                          <p:val>
-                                            <p:strVal val="#ppt_x-0.05"/>
-                                          </p:val>
-                                        </p:tav>
-                                        <p:tav tm="100000">
-                                          <p:val>
-                                            <p:strVal val="#ppt_x"/>
-                                          </p:val>
-                                        </p:tav>
-                                      </p:tavLst>
-                                    </p:anim>
-                                    <p:anim calcmode="lin" valueType="num">
-                                      <p:cBhvr>
-                                        <p:cTn id="21" dur="100" accel="100000" fill="hold">
-                                          <p:stCondLst>
-                                            <p:cond delay="400"/>
-                                          </p:stCondLst>
-                                        </p:cTn>
-                                        <p:tgtEl>
-                                          <p:spTgt spid="4"/>
-                                        </p:tgtEl>
-                                        <p:attrNameLst>
-                                          <p:attrName>ppt_y</p:attrName>
-                                        </p:attrNameLst>
-                                      </p:cBhvr>
-                                      <p:tavLst>
-                                        <p:tav tm="0">
-                                          <p:val>
-                                            <p:strVal val="#ppt_y+0.1"/>
-                                          </p:val>
-                                        </p:tav>
-                                        <p:tav tm="100000">
-                                          <p:val>
-                                            <p:strVal val="#ppt_y"/>
-                                          </p:val>
-                                        </p:tav>
-                                      </p:tavLst>
-                                    </p:anim>
-                                  </p:childTnLst>
-                                </p:cTn>
-                              </p:par>
-                            </p:childTnLst>
-                          </p:cTn>
-                        </p:par>
-                        <p:par>
-                          <p:cTn id="22" fill="hold">
-                            <p:stCondLst>
-                              <p:cond delay="1040"/>
-                            </p:stCondLst>
-                            <p:childTnLst>
-                              <p:par>
-                                <p:cTn id="23" presetID="30" presetClass="entr" presetSubtype="0" fill="hold" grpId="0" nodeType="afterEffect">
-                                  <p:stCondLst>
-                                    <p:cond delay="80"/>
-                                  </p:stCondLst>
-                                  <p:childTnLst>
-                                    <p:set>
-                                      <p:cBhvr>
-                                        <p:cTn id="24" dur="1" fill="hold">
-                                          <p:stCondLst>
-                                            <p:cond delay="0"/>
-                                          </p:stCondLst>
-                                        </p:cTn>
-                                        <p:tgtEl>
-                                          <p:spTgt spid="5"/>
-                                        </p:tgtEl>
-                                        <p:attrNameLst>
-                                          <p:attrName>style.visibility</p:attrName>
-                                        </p:attrNameLst>
-                                      </p:cBhvr>
-                                      <p:to>
-                                        <p:strVal val="visible"/>
-                                      </p:to>
-                                    </p:set>
-                                    <p:animEffect transition="in" filter="fade">
-                                      <p:cBhvr>
-                                        <p:cTn id="25" dur="400" decel="100000"/>
-                                        <p:tgtEl>
-                                          <p:spTgt spid="5"/>
-                                        </p:tgtEl>
-                                      </p:cBhvr>
-                                    </p:animEffect>
-                                    <p:anim calcmode="lin" valueType="num">
-                                      <p:cBhvr>
-                                        <p:cTn id="26" dur="400" decel="100000" fill="hold"/>
-                                        <p:tgtEl>
-                                          <p:spTgt spid="5"/>
-                                        </p:tgtEl>
-                                        <p:attrNameLst>
-                                          <p:attrName>style.rotation</p:attrName>
-                                        </p:attrNameLst>
-                                      </p:cBhvr>
-                                      <p:tavLst>
-                                        <p:tav tm="0">
-                                          <p:val>
-                                            <p:fltVal val="-90"/>
-                                          </p:val>
-                                        </p:tav>
-                                        <p:tav tm="100000">
-                                          <p:val>
-                                            <p:fltVal val="0"/>
-                                          </p:val>
-                                        </p:tav>
-                                      </p:tavLst>
-                                    </p:anim>
-                                    <p:anim calcmode="lin" valueType="num">
-                                      <p:cBhvr>
-                                        <p:cTn id="27" dur="400" decel="100000" fill="hold"/>
-                                        <p:tgtEl>
-                                          <p:spTgt spid="5"/>
-                                        </p:tgtEl>
-                                        <p:attrNameLst>
-                                          <p:attrName>ppt_x</p:attrName>
-                                        </p:attrNameLst>
-                                      </p:cBhvr>
-                                      <p:tavLst>
-                                        <p:tav tm="0">
-                                          <p:val>
-                                            <p:strVal val="#ppt_x+0.4"/>
-                                          </p:val>
-                                        </p:tav>
-                                        <p:tav tm="100000">
-                                          <p:val>
-                                            <p:strVal val="#ppt_x-0.05"/>
-                                          </p:val>
-                                        </p:tav>
-                                      </p:tavLst>
-                                    </p:anim>
-                                    <p:anim calcmode="lin" valueType="num">
-                                      <p:cBhvr>
-                                        <p:cTn id="28" dur="400" decel="100000" fill="hold"/>
-                                        <p:tgtEl>
-                                          <p:spTgt spid="5"/>
-                                        </p:tgtEl>
-                                        <p:attrNameLst>
-                                          <p:attrName>ppt_y</p:attrName>
-                                        </p:attrNameLst>
-                                      </p:cBhvr>
-                                      <p:tavLst>
-                                        <p:tav tm="0">
-                                          <p:val>
-                                            <p:strVal val="#ppt_y-0.4"/>
-                                          </p:val>
-                                        </p:tav>
-                                        <p:tav tm="100000">
-                                          <p:val>
-                                            <p:strVal val="#ppt_y+0.1"/>
-                                          </p:val>
-                                        </p:tav>
-                                      </p:tavLst>
-                                    </p:anim>
-                                    <p:anim calcmode="lin" valueType="num">
-                                      <p:cBhvr>
-                                        <p:cTn id="29" dur="100" accel="100000" fill="hold">
-                                          <p:stCondLst>
-                                            <p:cond delay="400"/>
-                                          </p:stCondLst>
-                                        </p:cTn>
-                                        <p:tgtEl>
-                                          <p:spTgt spid="5"/>
-                                        </p:tgtEl>
-                                        <p:attrNameLst>
-                                          <p:attrName>ppt_x</p:attrName>
-                                        </p:attrNameLst>
-                                      </p:cBhvr>
-                                      <p:tavLst>
-                                        <p:tav tm="0">
-                                          <p:val>
-                                            <p:strVal val="#ppt_x-0.05"/>
-                                          </p:val>
-                                        </p:tav>
-                                        <p:tav tm="100000">
-                                          <p:val>
-                                            <p:strVal val="#ppt_x"/>
-                                          </p:val>
-                                        </p:tav>
-                                      </p:tavLst>
-                                    </p:anim>
-                                    <p:anim calcmode="lin" valueType="num">
-                                      <p:cBhvr>
-                                        <p:cTn id="30" dur="100" accel="100000" fill="hold">
-                                          <p:stCondLst>
-                                            <p:cond delay="400"/>
-                                          </p:stCondLst>
-                                        </p:cTn>
-                                        <p:tgtEl>
-                                          <p:spTgt spid="5"/>
-                                        </p:tgtEl>
-                                        <p:attrNameLst>
-                                          <p:attrName>ppt_y</p:attrName>
-                                        </p:attrNameLst>
-                                      </p:cBhvr>
-                                      <p:tavLst>
-                                        <p:tav tm="0">
-                                          <p:val>
-                                            <p:strVal val="#ppt_y+0.1"/>
-                                          </p:val>
-                                        </p:tav>
-                                        <p:tav tm="100000">
-                                          <p:val>
-                                            <p:strVal val="#ppt_y"/>
-                                          </p:val>
-                                        </p:tav>
-                                      </p:tavLst>
-                                    </p:anim>
-                                  </p:childTnLst>
-                                </p:cTn>
-                              </p:par>
-                            </p:childTnLst>
-                          </p:cTn>
-                        </p:par>
-                        <p:par>
-                          <p:cTn id="31" fill="hold">
-                            <p:stCondLst>
-                              <p:cond delay="1620"/>
-                            </p:stCondLst>
-                            <p:childTnLst>
-                              <p:par>
-                                <p:cTn id="32" presetID="30" presetClass="entr" presetSubtype="0" fill="hold" grpId="0" nodeType="afterEffect">
-                                  <p:stCondLst>
-                                    <p:cond delay="120"/>
-                                  </p:stCondLst>
-                                  <p:childTnLst>
-                                    <p:set>
-                                      <p:cBhvr>
-                                        <p:cTn id="33" dur="1" fill="hold">
-                                          <p:stCondLst>
-                                            <p:cond delay="0"/>
-                                          </p:stCondLst>
-                                        </p:cTn>
-                                        <p:tgtEl>
-                                          <p:spTgt spid="6"/>
-                                        </p:tgtEl>
-                                        <p:attrNameLst>
-                                          <p:attrName>style.visibility</p:attrName>
-                                        </p:attrNameLst>
-                                      </p:cBhvr>
-                                      <p:to>
-                                        <p:strVal val="visible"/>
-                                      </p:to>
-                                    </p:set>
-                                    <p:animEffect transition="in" filter="fade">
-                                      <p:cBhvr>
-                                        <p:cTn id="34" dur="400" decel="100000"/>
-                                        <p:tgtEl>
-                                          <p:spTgt spid="6"/>
-                                        </p:tgtEl>
-                                      </p:cBhvr>
-                                    </p:animEffect>
-                                    <p:anim calcmode="lin" valueType="num">
-                                      <p:cBhvr>
-                                        <p:cTn id="35" dur="400" decel="100000" fill="hold"/>
-                                        <p:tgtEl>
-                                          <p:spTgt spid="6"/>
-                                        </p:tgtEl>
-                                        <p:attrNameLst>
-                                          <p:attrName>style.rotation</p:attrName>
-                                        </p:attrNameLst>
-                                      </p:cBhvr>
-                                      <p:tavLst>
-                                        <p:tav tm="0">
-                                          <p:val>
-                                            <p:fltVal val="-90"/>
-                                          </p:val>
-                                        </p:tav>
-                                        <p:tav tm="100000">
-                                          <p:val>
-                                            <p:fltVal val="0"/>
-                                          </p:val>
-                                        </p:tav>
-                                      </p:tavLst>
-                                    </p:anim>
-                                    <p:anim calcmode="lin" valueType="num">
-                                      <p:cBhvr>
-                                        <p:cTn id="36" dur="400" decel="100000" fill="hold"/>
-                                        <p:tgtEl>
-                                          <p:spTgt spid="6"/>
-                                        </p:tgtEl>
-                                        <p:attrNameLst>
-                                          <p:attrName>ppt_x</p:attrName>
-                                        </p:attrNameLst>
-                                      </p:cBhvr>
-                                      <p:tavLst>
-                                        <p:tav tm="0">
-                                          <p:val>
-                                            <p:strVal val="#ppt_x+0.4"/>
-                                          </p:val>
-                                        </p:tav>
-                                        <p:tav tm="100000">
-                                          <p:val>
-                                            <p:strVal val="#ppt_x-0.05"/>
-                                          </p:val>
-                                        </p:tav>
-                                      </p:tavLst>
-                                    </p:anim>
-                                    <p:anim calcmode="lin" valueType="num">
-                                      <p:cBhvr>
-                                        <p:cTn id="37" dur="400" decel="100000" fill="hold"/>
-                                        <p:tgtEl>
-                                          <p:spTgt spid="6"/>
-                                        </p:tgtEl>
-                                        <p:attrNameLst>
-                                          <p:attrName>ppt_y</p:attrName>
-                                        </p:attrNameLst>
-                                      </p:cBhvr>
-                                      <p:tavLst>
-                                        <p:tav tm="0">
-                                          <p:val>
-                                            <p:strVal val="#ppt_y-0.4"/>
-                                          </p:val>
-                                        </p:tav>
-                                        <p:tav tm="100000">
-                                          <p:val>
-                                            <p:strVal val="#ppt_y+0.1"/>
-                                          </p:val>
-                                        </p:tav>
-                                      </p:tavLst>
-                                    </p:anim>
-                                    <p:anim calcmode="lin" valueType="num">
-                                      <p:cBhvr>
-                                        <p:cTn id="38" dur="100" accel="100000" fill="hold">
-                                          <p:stCondLst>
-                                            <p:cond delay="400"/>
-                                          </p:stCondLst>
-                                        </p:cTn>
-                                        <p:tgtEl>
-                                          <p:spTgt spid="6"/>
-                                        </p:tgtEl>
-                                        <p:attrNameLst>
-                                          <p:attrName>ppt_x</p:attrName>
-                                        </p:attrNameLst>
-                                      </p:cBhvr>
-                                      <p:tavLst>
-                                        <p:tav tm="0">
-                                          <p:val>
-                                            <p:strVal val="#ppt_x-0.05"/>
-                                          </p:val>
-                                        </p:tav>
-                                        <p:tav tm="100000">
-                                          <p:val>
-                                            <p:strVal val="#ppt_x"/>
-                                          </p:val>
-                                        </p:tav>
-                                      </p:tavLst>
-                                    </p:anim>
-                                    <p:anim calcmode="lin" valueType="num">
-                                      <p:cBhvr>
-                                        <p:cTn id="39" dur="100" accel="100000" fill="hold">
-                                          <p:stCondLst>
-                                            <p:cond delay="400"/>
-                                          </p:stCondLst>
-                                        </p:cTn>
-                                        <p:tgtEl>
-                                          <p:spTgt spid="6"/>
-                                        </p:tgtEl>
-                                        <p:attrNameLst>
-                                          <p:attrName>ppt_y</p:attrName>
-                                        </p:attrNameLst>
-                                      </p:cBhvr>
-                                      <p:tavLst>
-                                        <p:tav tm="0">
-                                          <p:val>
-                                            <p:strVal val="#ppt_y+0.1"/>
-                                          </p:val>
-                                        </p:tav>
-                                        <p:tav tm="100000">
-                                          <p:val>
-                                            <p:strVal val="#ppt_y"/>
-                                          </p:val>
-                                        </p:tav>
-                                      </p:tavLst>
-                                    </p:anim>
-                                  </p:childTnLst>
-                                </p:cTn>
-                              </p:par>
-                            </p:childTnLst>
-                          </p:cTn>
-                        </p:par>
-                        <p:par>
-                          <p:cTn id="40" fill="hold">
-                            <p:stCondLst>
-                              <p:cond delay="2240"/>
-                            </p:stCondLst>
-                            <p:childTnLst>
-                              <p:par>
-                                <p:cTn id="41" presetID="30" presetClass="entr" presetSubtype="0" fill="hold" grpId="0" nodeType="afterEffect">
-                                  <p:stCondLst>
-                                    <p:cond delay="160"/>
-                                  </p:stCondLst>
-                                  <p:childTnLst>
-                                    <p:set>
-                                      <p:cBhvr>
-                                        <p:cTn id="42" dur="1" fill="hold">
-                                          <p:stCondLst>
-                                            <p:cond delay="0"/>
-                                          </p:stCondLst>
-                                        </p:cTn>
-                                        <p:tgtEl>
-                                          <p:spTgt spid="7"/>
-                                        </p:tgtEl>
-                                        <p:attrNameLst>
-                                          <p:attrName>style.visibility</p:attrName>
-                                        </p:attrNameLst>
-                                      </p:cBhvr>
-                                      <p:to>
-                                        <p:strVal val="visible"/>
-                                      </p:to>
-                                    </p:set>
-                                    <p:animEffect transition="in" filter="fade">
-                                      <p:cBhvr>
-                                        <p:cTn id="43" dur="400" decel="100000"/>
-                                        <p:tgtEl>
-                                          <p:spTgt spid="7"/>
-                                        </p:tgtEl>
-                                      </p:cBhvr>
-                                    </p:animEffect>
-                                    <p:anim calcmode="lin" valueType="num">
-                                      <p:cBhvr>
-                                        <p:cTn id="44" dur="400" decel="100000" fill="hold"/>
-                                        <p:tgtEl>
-                                          <p:spTgt spid="7"/>
-                                        </p:tgtEl>
-                                        <p:attrNameLst>
-                                          <p:attrName>style.rotation</p:attrName>
-                                        </p:attrNameLst>
-                                      </p:cBhvr>
-                                      <p:tavLst>
-                                        <p:tav tm="0">
-                                          <p:val>
-                                            <p:fltVal val="-90"/>
-                                          </p:val>
-                                        </p:tav>
-                                        <p:tav tm="100000">
-                                          <p:val>
-                                            <p:fltVal val="0"/>
-                                          </p:val>
-                                        </p:tav>
-                                      </p:tavLst>
-                                    </p:anim>
-                                    <p:anim calcmode="lin" valueType="num">
-                                      <p:cBhvr>
-                                        <p:cTn id="45" dur="400" decel="100000" fill="hold"/>
-                                        <p:tgtEl>
-                                          <p:spTgt spid="7"/>
-                                        </p:tgtEl>
-                                        <p:attrNameLst>
-                                          <p:attrName>ppt_x</p:attrName>
-                                        </p:attrNameLst>
-                                      </p:cBhvr>
-                                      <p:tavLst>
-                                        <p:tav tm="0">
-                                          <p:val>
-                                            <p:strVal val="#ppt_x+0.4"/>
-                                          </p:val>
-                                        </p:tav>
-                                        <p:tav tm="100000">
-                                          <p:val>
-                                            <p:strVal val="#ppt_x-0.05"/>
-                                          </p:val>
-                                        </p:tav>
-                                      </p:tavLst>
-                                    </p:anim>
-                                    <p:anim calcmode="lin" valueType="num">
-                                      <p:cBhvr>
-                                        <p:cTn id="46" dur="400" decel="100000" fill="hold"/>
-                                        <p:tgtEl>
-                                          <p:spTgt spid="7"/>
-                                        </p:tgtEl>
-                                        <p:attrNameLst>
-                                          <p:attrName>ppt_y</p:attrName>
-                                        </p:attrNameLst>
-                                      </p:cBhvr>
-                                      <p:tavLst>
-                                        <p:tav tm="0">
-                                          <p:val>
-                                            <p:strVal val="#ppt_y-0.4"/>
-                                          </p:val>
-                                        </p:tav>
-                                        <p:tav tm="100000">
-                                          <p:val>
-                                            <p:strVal val="#ppt_y+0.1"/>
-                                          </p:val>
-                                        </p:tav>
-                                      </p:tavLst>
-                                    </p:anim>
-                                    <p:anim calcmode="lin" valueType="num">
-                                      <p:cBhvr>
-                                        <p:cTn id="47" dur="100" accel="100000" fill="hold">
-                                          <p:stCondLst>
-                                            <p:cond delay="400"/>
-                                          </p:stCondLst>
-                                        </p:cTn>
-                                        <p:tgtEl>
-                                          <p:spTgt spid="7"/>
-                                        </p:tgtEl>
-                                        <p:attrNameLst>
-                                          <p:attrName>ppt_x</p:attrName>
-                                        </p:attrNameLst>
-                                      </p:cBhvr>
-                                      <p:tavLst>
-                                        <p:tav tm="0">
-                                          <p:val>
-                                            <p:strVal val="#ppt_x-0.05"/>
-                                          </p:val>
-                                        </p:tav>
-                                        <p:tav tm="100000">
-                                          <p:val>
-                                            <p:strVal val="#ppt_x"/>
-                                          </p:val>
-                                        </p:tav>
-                                      </p:tavLst>
-                                    </p:anim>
-                                    <p:anim calcmode="lin" valueType="num">
-                                      <p:cBhvr>
-                                        <p:cTn id="48" dur="100" accel="100000" fill="hold">
-                                          <p:stCondLst>
-                                            <p:cond delay="400"/>
-                                          </p:stCondLst>
-                                        </p:cTn>
-                                        <p:tgtEl>
-                                          <p:spTgt spid="7"/>
-                                        </p:tgtEl>
-                                        <p:attrNameLst>
-                                          <p:attrName>ppt_y</p:attrName>
-                                        </p:attrNameLst>
-                                      </p:cBhvr>
-                                      <p:tavLst>
-                                        <p:tav tm="0">
-                                          <p:val>
-                                            <p:strVal val="#ppt_y+0.1"/>
-                                          </p:val>
-                                        </p:tav>
-                                        <p:tav tm="100000">
-                                          <p:val>
-                                            <p:strVal val="#ppt_y"/>
-                                          </p:val>
-                                        </p:tav>
-                                      </p:tavLst>
-                                    </p:anim>
-                                  </p:childTnLst>
-                                </p:cTn>
-                              </p:par>
-                            </p:childTnLst>
-                          </p:cTn>
-                        </p:par>
-                        <p:par>
-                          <p:cTn id="49" fill="hold">
-                            <p:stCondLst>
-                              <p:cond delay="2900"/>
-                            </p:stCondLst>
-                            <p:childTnLst>
-                              <p:par>
-                                <p:cTn id="50" presetID="30" presetClass="entr" presetSubtype="0" fill="hold" grpId="0" nodeType="afterEffect">
-                                  <p:stCondLst>
-                                    <p:cond delay="200"/>
-                                  </p:stCondLst>
-                                  <p:childTnLst>
-                                    <p:set>
-                                      <p:cBhvr>
-                                        <p:cTn id="51" dur="1" fill="hold">
-                                          <p:stCondLst>
-                                            <p:cond delay="0"/>
-                                          </p:stCondLst>
-                                        </p:cTn>
-                                        <p:tgtEl>
-                                          <p:spTgt spid="8"/>
-                                        </p:tgtEl>
-                                        <p:attrNameLst>
-                                          <p:attrName>style.visibility</p:attrName>
-                                        </p:attrNameLst>
-                                      </p:cBhvr>
-                                      <p:to>
-                                        <p:strVal val="visible"/>
-                                      </p:to>
-                                    </p:set>
-                                    <p:animEffect transition="in" filter="fade">
-                                      <p:cBhvr>
-                                        <p:cTn id="52" dur="400" decel="100000"/>
-                                        <p:tgtEl>
-                                          <p:spTgt spid="8"/>
-                                        </p:tgtEl>
-                                      </p:cBhvr>
-                                    </p:animEffect>
-                                    <p:anim calcmode="lin" valueType="num">
-                                      <p:cBhvr>
-                                        <p:cTn id="53" dur="400" decel="100000" fill="hold"/>
-                                        <p:tgtEl>
-                                          <p:spTgt spid="8"/>
-                                        </p:tgtEl>
-                                        <p:attrNameLst>
-                                          <p:attrName>style.rotation</p:attrName>
-                                        </p:attrNameLst>
-                                      </p:cBhvr>
-                                      <p:tavLst>
-                                        <p:tav tm="0">
-                                          <p:val>
-                                            <p:fltVal val="-90"/>
-                                          </p:val>
-                                        </p:tav>
-                                        <p:tav tm="100000">
-                                          <p:val>
-                                            <p:fltVal val="0"/>
-                                          </p:val>
-                                        </p:tav>
-                                      </p:tavLst>
-                                    </p:anim>
-                                    <p:anim calcmode="lin" valueType="num">
-                                      <p:cBhvr>
-                                        <p:cTn id="54" dur="400" decel="100000" fill="hold"/>
-                                        <p:tgtEl>
-                                          <p:spTgt spid="8"/>
-                                        </p:tgtEl>
-                                        <p:attrNameLst>
-                                          <p:attrName>ppt_x</p:attrName>
-                                        </p:attrNameLst>
-                                      </p:cBhvr>
-                                      <p:tavLst>
-                                        <p:tav tm="0">
-                                          <p:val>
-                                            <p:strVal val="#ppt_x+0.4"/>
-                                          </p:val>
-                                        </p:tav>
-                                        <p:tav tm="100000">
-                                          <p:val>
-                                            <p:strVal val="#ppt_x-0.05"/>
-                                          </p:val>
-                                        </p:tav>
-                                      </p:tavLst>
-                                    </p:anim>
-                                    <p:anim calcmode="lin" valueType="num">
-                                      <p:cBhvr>
-                                        <p:cTn id="55" dur="400" decel="100000" fill="hold"/>
-                                        <p:tgtEl>
-                                          <p:spTgt spid="8"/>
-                                        </p:tgtEl>
-                                        <p:attrNameLst>
-                                          <p:attrName>ppt_y</p:attrName>
-                                        </p:attrNameLst>
-                                      </p:cBhvr>
-                                      <p:tavLst>
-                                        <p:tav tm="0">
-                                          <p:val>
-                                            <p:strVal val="#ppt_y-0.4"/>
-                                          </p:val>
-                                        </p:tav>
-                                        <p:tav tm="100000">
-                                          <p:val>
-                                            <p:strVal val="#ppt_y+0.1"/>
-                                          </p:val>
-                                        </p:tav>
-                                      </p:tavLst>
-                                    </p:anim>
-                                    <p:anim calcmode="lin" valueType="num">
-                                      <p:cBhvr>
-                                        <p:cTn id="56" dur="100" accel="100000" fill="hold">
-                                          <p:stCondLst>
-                                            <p:cond delay="400"/>
-                                          </p:stCondLst>
-                                        </p:cTn>
-                                        <p:tgtEl>
-                                          <p:spTgt spid="8"/>
-                                        </p:tgtEl>
-                                        <p:attrNameLst>
-                                          <p:attrName>ppt_x</p:attrName>
-                                        </p:attrNameLst>
-                                      </p:cBhvr>
-                                      <p:tavLst>
-                                        <p:tav tm="0">
-                                          <p:val>
-                                            <p:strVal val="#ppt_x-0.05"/>
-                                          </p:val>
-                                        </p:tav>
-                                        <p:tav tm="100000">
-                                          <p:val>
-                                            <p:strVal val="#ppt_x"/>
-                                          </p:val>
-                                        </p:tav>
-                                      </p:tavLst>
-                                    </p:anim>
-                                    <p:anim calcmode="lin" valueType="num">
-                                      <p:cBhvr>
-                                        <p:cTn id="57" dur="100" accel="100000" fill="hold">
-                                          <p:stCondLst>
-                                            <p:cond delay="400"/>
-                                          </p:stCondLst>
-                                        </p:cTn>
-                                        <p:tgtEl>
-                                          <p:spTgt spid="8"/>
-                                        </p:tgtEl>
-                                        <p:attrNameLst>
-                                          <p:attrName>ppt_y</p:attrName>
-                                        </p:attrNameLst>
-                                      </p:cBhvr>
-                                      <p:tavLst>
-                                        <p:tav tm="0">
-                                          <p:val>
-                                            <p:strVal val="#ppt_y+0.1"/>
-                                          </p:val>
-                                        </p:tav>
-                                        <p:tav tm="100000">
-                                          <p:val>
-                                            <p:strVal val="#ppt_y"/>
-                                          </p:val>
-                                        </p:tav>
-                                      </p:tavLst>
-                                    </p:anim>
-                                  </p:childTnLst>
-                                </p:cTn>
-                              </p:par>
-                            </p:childTnLst>
-                          </p:cTn>
-                        </p:par>
-                        <p:par>
-                          <p:cTn id="58" fill="hold">
-                            <p:stCondLst>
-                              <p:cond delay="3600"/>
-                            </p:stCondLst>
-                            <p:childTnLst>
-                              <p:par>
-                                <p:cTn id="59" presetID="30" presetClass="entr" presetSubtype="0" fill="hold" grpId="0" nodeType="afterEffect">
-                                  <p:stCondLst>
-                                    <p:cond delay="240"/>
-                                  </p:stCondLst>
-                                  <p:childTnLst>
-                                    <p:set>
-                                      <p:cBhvr>
-                                        <p:cTn id="60" dur="1" fill="hold">
-                                          <p:stCondLst>
-                                            <p:cond delay="0"/>
-                                          </p:stCondLst>
-                                        </p:cTn>
-                                        <p:tgtEl>
-                                          <p:spTgt spid="9"/>
-                                        </p:tgtEl>
-                                        <p:attrNameLst>
-                                          <p:attrName>style.visibility</p:attrName>
-                                        </p:attrNameLst>
-                                      </p:cBhvr>
-                                      <p:to>
-                                        <p:strVal val="visible"/>
-                                      </p:to>
-                                    </p:set>
-                                    <p:animEffect transition="in" filter="fade">
-                                      <p:cBhvr>
-                                        <p:cTn id="61" dur="400" decel="100000"/>
-                                        <p:tgtEl>
-                                          <p:spTgt spid="9"/>
-                                        </p:tgtEl>
-                                      </p:cBhvr>
-                                    </p:animEffect>
-                                    <p:anim calcmode="lin" valueType="num">
-                                      <p:cBhvr>
-                                        <p:cTn id="62" dur="400" decel="100000" fill="hold"/>
-                                        <p:tgtEl>
-                                          <p:spTgt spid="9"/>
-                                        </p:tgtEl>
-                                        <p:attrNameLst>
-                                          <p:attrName>style.rotation</p:attrName>
-                                        </p:attrNameLst>
-                                      </p:cBhvr>
-                                      <p:tavLst>
-                                        <p:tav tm="0">
-                                          <p:val>
-                                            <p:fltVal val="-90"/>
-                                          </p:val>
-                                        </p:tav>
-                                        <p:tav tm="100000">
-                                          <p:val>
-                                            <p:fltVal val="0"/>
-                                          </p:val>
-                                        </p:tav>
-                                      </p:tavLst>
-                                    </p:anim>
-                                    <p:anim calcmode="lin" valueType="num">
-                                      <p:cBhvr>
-                                        <p:cTn id="63" dur="400" decel="100000" fill="hold"/>
-                                        <p:tgtEl>
-                                          <p:spTgt spid="9"/>
-                                        </p:tgtEl>
-                                        <p:attrNameLst>
-                                          <p:attrName>ppt_x</p:attrName>
-                                        </p:attrNameLst>
-                                      </p:cBhvr>
-                                      <p:tavLst>
-                                        <p:tav tm="0">
-                                          <p:val>
-                                            <p:strVal val="#ppt_x+0.4"/>
-                                          </p:val>
-                                        </p:tav>
-                                        <p:tav tm="100000">
-                                          <p:val>
-                                            <p:strVal val="#ppt_x-0.05"/>
-                                          </p:val>
-                                        </p:tav>
-                                      </p:tavLst>
-                                    </p:anim>
-                                    <p:anim calcmode="lin" valueType="num">
-                                      <p:cBhvr>
-                                        <p:cTn id="64" dur="400" decel="100000" fill="hold"/>
-                                        <p:tgtEl>
-                                          <p:spTgt spid="9"/>
-                                        </p:tgtEl>
-                                        <p:attrNameLst>
-                                          <p:attrName>ppt_y</p:attrName>
-                                        </p:attrNameLst>
-                                      </p:cBhvr>
-                                      <p:tavLst>
-                                        <p:tav tm="0">
-                                          <p:val>
-                                            <p:strVal val="#ppt_y-0.4"/>
-                                          </p:val>
-                                        </p:tav>
-                                        <p:tav tm="100000">
-                                          <p:val>
-                                            <p:strVal val="#ppt_y+0.1"/>
-                                          </p:val>
-                                        </p:tav>
-                                      </p:tavLst>
-                                    </p:anim>
-                                    <p:anim calcmode="lin" valueType="num">
-                                      <p:cBhvr>
-                                        <p:cTn id="65" dur="100" accel="100000" fill="hold">
-                                          <p:stCondLst>
-                                            <p:cond delay="400"/>
-                                          </p:stCondLst>
-                                        </p:cTn>
-                                        <p:tgtEl>
-                                          <p:spTgt spid="9"/>
-                                        </p:tgtEl>
-                                        <p:attrNameLst>
-                                          <p:attrName>ppt_x</p:attrName>
-                                        </p:attrNameLst>
-                                      </p:cBhvr>
-                                      <p:tavLst>
-                                        <p:tav tm="0">
-                                          <p:val>
-                                            <p:strVal val="#ppt_x-0.05"/>
-                                          </p:val>
-                                        </p:tav>
-                                        <p:tav tm="100000">
-                                          <p:val>
-                                            <p:strVal val="#ppt_x"/>
-                                          </p:val>
-                                        </p:tav>
-                                      </p:tavLst>
-                                    </p:anim>
-                                    <p:anim calcmode="lin" valueType="num">
-                                      <p:cBhvr>
-                                        <p:cTn id="66" dur="100" accel="100000" fill="hold">
-                                          <p:stCondLst>
-                                            <p:cond delay="400"/>
-                                          </p:stCondLst>
-                                        </p:cTn>
-                                        <p:tgtEl>
-                                          <p:spTgt spid="9"/>
-                                        </p:tgtEl>
-                                        <p:attrNameLst>
-                                          <p:attrName>ppt_y</p:attrName>
-                                        </p:attrNameLst>
-                                      </p:cBhvr>
-                                      <p:tavLst>
-                                        <p:tav tm="0">
-                                          <p:val>
-                                            <p:strVal val="#ppt_y+0.1"/>
-                                          </p:val>
-                                        </p:tav>
-                                        <p:tav tm="100000">
-                                          <p:val>
-                                            <p:strVal val="#ppt_y"/>
-                                          </p:val>
-                                        </p:tav>
-                                      </p:tavLst>
-                                    </p:anim>
-                                  </p:childTnLst>
-                                </p:cTn>
-                              </p:par>
-                            </p:childTnLst>
-                          </p:cTn>
-                        </p:par>
-                        <p:par>
-                          <p:cTn id="67" fill="hold">
-                            <p:stCondLst>
-                              <p:cond delay="4340"/>
-                            </p:stCondLst>
-                            <p:childTnLst>
-                              <p:par>
-                                <p:cTn id="68" presetID="30" presetClass="entr" presetSubtype="0" fill="hold" grpId="0" nodeType="afterEffect">
-                                  <p:stCondLst>
-                                    <p:cond delay="280"/>
-                                  </p:stCondLst>
-                                  <p:childTnLst>
-                                    <p:set>
-                                      <p:cBhvr>
-                                        <p:cTn id="69" dur="1" fill="hold">
-                                          <p:stCondLst>
-                                            <p:cond delay="0"/>
-                                          </p:stCondLst>
-                                        </p:cTn>
-                                        <p:tgtEl>
-                                          <p:spTgt spid="10"/>
-                                        </p:tgtEl>
-                                        <p:attrNameLst>
-                                          <p:attrName>style.visibility</p:attrName>
-                                        </p:attrNameLst>
-                                      </p:cBhvr>
-                                      <p:to>
-                                        <p:strVal val="visible"/>
-                                      </p:to>
-                                    </p:set>
-                                    <p:animEffect transition="in" filter="fade">
-                                      <p:cBhvr>
-                                        <p:cTn id="70" dur="400" decel="100000"/>
-                                        <p:tgtEl>
-                                          <p:spTgt spid="10"/>
-                                        </p:tgtEl>
-                                      </p:cBhvr>
-                                    </p:animEffect>
-                                    <p:anim calcmode="lin" valueType="num">
-                                      <p:cBhvr>
-                                        <p:cTn id="71" dur="400" decel="100000" fill="hold"/>
-                                        <p:tgtEl>
-                                          <p:spTgt spid="10"/>
-                                        </p:tgtEl>
-                                        <p:attrNameLst>
-                                          <p:attrName>style.rotation</p:attrName>
-                                        </p:attrNameLst>
-                                      </p:cBhvr>
-                                      <p:tavLst>
-                                        <p:tav tm="0">
-                                          <p:val>
-                                            <p:fltVal val="-90"/>
-                                          </p:val>
-                                        </p:tav>
-                                        <p:tav tm="100000">
-                                          <p:val>
-                                            <p:fltVal val="0"/>
-                                          </p:val>
-                                        </p:tav>
-                                      </p:tavLst>
-                                    </p:anim>
-                                    <p:anim calcmode="lin" valueType="num">
-                                      <p:cBhvr>
-                                        <p:cTn id="72" dur="400" decel="100000" fill="hold"/>
-                                        <p:tgtEl>
-                                          <p:spTgt spid="10"/>
-                                        </p:tgtEl>
-                                        <p:attrNameLst>
-                                          <p:attrName>ppt_x</p:attrName>
-                                        </p:attrNameLst>
-                                      </p:cBhvr>
-                                      <p:tavLst>
-                                        <p:tav tm="0">
-                                          <p:val>
-                                            <p:strVal val="#ppt_x+0.4"/>
-                                          </p:val>
-                                        </p:tav>
-                                        <p:tav tm="100000">
-                                          <p:val>
-                                            <p:strVal val="#ppt_x-0.05"/>
-                                          </p:val>
-                                        </p:tav>
-                                      </p:tavLst>
-                                    </p:anim>
-                                    <p:anim calcmode="lin" valueType="num">
-                                      <p:cBhvr>
-                                        <p:cTn id="73" dur="400" decel="100000" fill="hold"/>
-                                        <p:tgtEl>
-                                          <p:spTgt spid="10"/>
-                                        </p:tgtEl>
-                                        <p:attrNameLst>
-                                          <p:attrName>ppt_y</p:attrName>
-                                        </p:attrNameLst>
-                                      </p:cBhvr>
-                                      <p:tavLst>
-                                        <p:tav tm="0">
-                                          <p:val>
-                                            <p:strVal val="#ppt_y-0.4"/>
-                                          </p:val>
-                                        </p:tav>
-                                        <p:tav tm="100000">
-                                          <p:val>
-                                            <p:strVal val="#ppt_y+0.1"/>
-                                          </p:val>
-                                        </p:tav>
-                                      </p:tavLst>
-                                    </p:anim>
-                                    <p:anim calcmode="lin" valueType="num">
-                                      <p:cBhvr>
-                                        <p:cTn id="74" dur="100" accel="100000" fill="hold">
-                                          <p:stCondLst>
-                                            <p:cond delay="400"/>
-                                          </p:stCondLst>
-                                        </p:cTn>
-                                        <p:tgtEl>
-                                          <p:spTgt spid="10"/>
-                                        </p:tgtEl>
-                                        <p:attrNameLst>
-                                          <p:attrName>ppt_x</p:attrName>
-                                        </p:attrNameLst>
-                                      </p:cBhvr>
-                                      <p:tavLst>
-                                        <p:tav tm="0">
-                                          <p:val>
-                                            <p:strVal val="#ppt_x-0.05"/>
-                                          </p:val>
-                                        </p:tav>
-                                        <p:tav tm="100000">
-                                          <p:val>
-                                            <p:strVal val="#ppt_x"/>
-                                          </p:val>
-                                        </p:tav>
-                                      </p:tavLst>
-                                    </p:anim>
-                                    <p:anim calcmode="lin" valueType="num">
-                                      <p:cBhvr>
-                                        <p:cTn id="75" dur="100" accel="100000" fill="hold">
-                                          <p:stCondLst>
-                                            <p:cond delay="400"/>
-                                          </p:stCondLst>
-                                        </p:cTn>
-                                        <p:tgtEl>
-                                          <p:spTgt spid="10"/>
-                                        </p:tgtEl>
-                                        <p:attrNameLst>
-                                          <p:attrName>ppt_y</p:attrName>
-                                        </p:attrNameLst>
-                                      </p:cBhvr>
-                                      <p:tavLst>
-                                        <p:tav tm="0">
-                                          <p:val>
-                                            <p:strVal val="#ppt_y+0.1"/>
-                                          </p:val>
-                                        </p:tav>
-                                        <p:tav tm="100000">
-                                          <p:val>
-                                            <p:strVal val="#ppt_y"/>
-                                          </p:val>
-                                        </p:tav>
-                                      </p:tavLst>
-                                    </p:anim>
-                                  </p:childTnLst>
-                                </p:cTn>
-                              </p:par>
-                            </p:childTnLst>
-                          </p:cTn>
-                        </p:par>
-                        <p:par>
-                          <p:cTn id="76" fill="hold">
-                            <p:stCondLst>
-                              <p:cond delay="5120"/>
-                            </p:stCondLst>
-                            <p:childTnLst>
-                              <p:par>
-                                <p:cTn id="77" presetID="30" presetClass="entr" presetSubtype="0" fill="hold" grpId="0" nodeType="afterEffect">
-                                  <p:stCondLst>
-                                    <p:cond delay="320"/>
-                                  </p:stCondLst>
-                                  <p:childTnLst>
-                                    <p:set>
-                                      <p:cBhvr>
-                                        <p:cTn id="78" dur="1" fill="hold">
-                                          <p:stCondLst>
-                                            <p:cond delay="0"/>
-                                          </p:stCondLst>
-                                        </p:cTn>
-                                        <p:tgtEl>
-                                          <p:spTgt spid="11"/>
-                                        </p:tgtEl>
-                                        <p:attrNameLst>
-                                          <p:attrName>style.visibility</p:attrName>
-                                        </p:attrNameLst>
-                                      </p:cBhvr>
-                                      <p:to>
-                                        <p:strVal val="visible"/>
-                                      </p:to>
-                                    </p:set>
-                                    <p:animEffect transition="in" filter="fade">
-                                      <p:cBhvr>
-                                        <p:cTn id="79" dur="400" decel="100000"/>
-                                        <p:tgtEl>
-                                          <p:spTgt spid="11"/>
-                                        </p:tgtEl>
-                                      </p:cBhvr>
-                                    </p:animEffect>
-                                    <p:anim calcmode="lin" valueType="num">
-                                      <p:cBhvr>
-                                        <p:cTn id="80" dur="400" decel="100000" fill="hold"/>
-                                        <p:tgtEl>
-                                          <p:spTgt spid="11"/>
-                                        </p:tgtEl>
-                                        <p:attrNameLst>
-                                          <p:attrName>style.rotation</p:attrName>
-                                        </p:attrNameLst>
-                                      </p:cBhvr>
-                                      <p:tavLst>
-                                        <p:tav tm="0">
-                                          <p:val>
-                                            <p:fltVal val="-90"/>
-                                          </p:val>
-                                        </p:tav>
-                                        <p:tav tm="100000">
-                                          <p:val>
-                                            <p:fltVal val="0"/>
-                                          </p:val>
-                                        </p:tav>
-                                      </p:tavLst>
-                                    </p:anim>
-                                    <p:anim calcmode="lin" valueType="num">
-                                      <p:cBhvr>
-                                        <p:cTn id="81" dur="400" decel="100000" fill="hold"/>
-                                        <p:tgtEl>
-                                          <p:spTgt spid="11"/>
-                                        </p:tgtEl>
-                                        <p:attrNameLst>
-                                          <p:attrName>ppt_x</p:attrName>
-                                        </p:attrNameLst>
-                                      </p:cBhvr>
-                                      <p:tavLst>
-                                        <p:tav tm="0">
-                                          <p:val>
-                                            <p:strVal val="#ppt_x+0.4"/>
-                                          </p:val>
-                                        </p:tav>
-                                        <p:tav tm="100000">
-                                          <p:val>
-                                            <p:strVal val="#ppt_x-0.05"/>
-                                          </p:val>
-                                        </p:tav>
-                                      </p:tavLst>
-                                    </p:anim>
-                                    <p:anim calcmode="lin" valueType="num">
-                                      <p:cBhvr>
-                                        <p:cTn id="82" dur="400" decel="100000" fill="hold"/>
-                                        <p:tgtEl>
-                                          <p:spTgt spid="11"/>
-                                        </p:tgtEl>
-                                        <p:attrNameLst>
-                                          <p:attrName>ppt_y</p:attrName>
-                                        </p:attrNameLst>
-                                      </p:cBhvr>
-                                      <p:tavLst>
-                                        <p:tav tm="0">
-                                          <p:val>
-                                            <p:strVal val="#ppt_y-0.4"/>
-                                          </p:val>
-                                        </p:tav>
-                                        <p:tav tm="100000">
-                                          <p:val>
-                                            <p:strVal val="#ppt_y+0.1"/>
-                                          </p:val>
-                                        </p:tav>
-                                      </p:tavLst>
-                                    </p:anim>
-                                    <p:anim calcmode="lin" valueType="num">
-                                      <p:cBhvr>
-                                        <p:cTn id="83" dur="100" accel="100000" fill="hold">
-                                          <p:stCondLst>
-                                            <p:cond delay="400"/>
-                                          </p:stCondLst>
-                                        </p:cTn>
-                                        <p:tgtEl>
-                                          <p:spTgt spid="11"/>
-                                        </p:tgtEl>
-                                        <p:attrNameLst>
-                                          <p:attrName>ppt_x</p:attrName>
-                                        </p:attrNameLst>
-                                      </p:cBhvr>
-                                      <p:tavLst>
-                                        <p:tav tm="0">
-                                          <p:val>
-                                            <p:strVal val="#ppt_x-0.05"/>
-                                          </p:val>
-                                        </p:tav>
-                                        <p:tav tm="100000">
-                                          <p:val>
-                                            <p:strVal val="#ppt_x"/>
-                                          </p:val>
-                                        </p:tav>
-                                      </p:tavLst>
-                                    </p:anim>
-                                    <p:anim calcmode="lin" valueType="num">
-                                      <p:cBhvr>
-                                        <p:cTn id="84" dur="100" accel="100000" fill="hold">
-                                          <p:stCondLst>
-                                            <p:cond delay="400"/>
-                                          </p:stCondLst>
-                                        </p:cTn>
-                                        <p:tgtEl>
-                                          <p:spTgt spid="11"/>
-                                        </p:tgtEl>
-                                        <p:attrNameLst>
-                                          <p:attrName>ppt_y</p:attrName>
-                                        </p:attrNameLst>
-                                      </p:cBhvr>
-                                      <p:tavLst>
-                                        <p:tav tm="0">
-                                          <p:val>
-                                            <p:strVal val="#ppt_y+0.1"/>
-                                          </p:val>
-                                        </p:tav>
-                                        <p:tav tm="100000">
-                                          <p:val>
-                                            <p:strVal val="#ppt_y"/>
-                                          </p:val>
-                                        </p:tav>
-                                      </p:tavLst>
-                                    </p:anim>
-                                  </p:childTnLst>
-                                </p:cTn>
-                              </p:par>
-                            </p:childTnLst>
-                          </p:cTn>
-                        </p:par>
-                        <p:par>
-                          <p:cTn id="85" fill="hold">
-                            <p:stCondLst>
-                              <p:cond delay="5940"/>
-                            </p:stCondLst>
-                            <p:childTnLst>
-                              <p:par>
-                                <p:cTn id="86" presetID="30" presetClass="entr" presetSubtype="0" fill="hold" grpId="0" nodeType="afterEffect">
-                                  <p:stCondLst>
-                                    <p:cond delay="360"/>
-                                  </p:stCondLst>
-                                  <p:childTnLst>
-                                    <p:set>
-                                      <p:cBhvr>
-                                        <p:cTn id="87" dur="1" fill="hold">
-                                          <p:stCondLst>
-                                            <p:cond delay="0"/>
-                                          </p:stCondLst>
-                                        </p:cTn>
-                                        <p:tgtEl>
-                                          <p:spTgt spid="12"/>
-                                        </p:tgtEl>
-                                        <p:attrNameLst>
-                                          <p:attrName>style.visibility</p:attrName>
-                                        </p:attrNameLst>
-                                      </p:cBhvr>
-                                      <p:to>
-                                        <p:strVal val="visible"/>
-                                      </p:to>
-                                    </p:set>
-                                    <p:animEffect transition="in" filter="fade">
-                                      <p:cBhvr>
-                                        <p:cTn id="88" dur="400" decel="100000"/>
-                                        <p:tgtEl>
-                                          <p:spTgt spid="12"/>
-                                        </p:tgtEl>
-                                      </p:cBhvr>
-                                    </p:animEffect>
-                                    <p:anim calcmode="lin" valueType="num">
-                                      <p:cBhvr>
-                                        <p:cTn id="89" dur="400" decel="100000" fill="hold"/>
-                                        <p:tgtEl>
-                                          <p:spTgt spid="12"/>
-                                        </p:tgtEl>
-                                        <p:attrNameLst>
-                                          <p:attrName>style.rotation</p:attrName>
-                                        </p:attrNameLst>
-                                      </p:cBhvr>
-                                      <p:tavLst>
-                                        <p:tav tm="0">
-                                          <p:val>
-                                            <p:fltVal val="-90"/>
-                                          </p:val>
-                                        </p:tav>
-                                        <p:tav tm="100000">
-                                          <p:val>
-                                            <p:fltVal val="0"/>
-                                          </p:val>
-                                        </p:tav>
-                                      </p:tavLst>
-                                    </p:anim>
-                                    <p:anim calcmode="lin" valueType="num">
-                                      <p:cBhvr>
-                                        <p:cTn id="90" dur="400" decel="100000" fill="hold"/>
-                                        <p:tgtEl>
-                                          <p:spTgt spid="12"/>
-                                        </p:tgtEl>
-                                        <p:attrNameLst>
-                                          <p:attrName>ppt_x</p:attrName>
-                                        </p:attrNameLst>
-                                      </p:cBhvr>
-                                      <p:tavLst>
-                                        <p:tav tm="0">
-                                          <p:val>
-                                            <p:strVal val="#ppt_x+0.4"/>
-                                          </p:val>
-                                        </p:tav>
-                                        <p:tav tm="100000">
-                                          <p:val>
-                                            <p:strVal val="#ppt_x-0.05"/>
-                                          </p:val>
-                                        </p:tav>
-                                      </p:tavLst>
-                                    </p:anim>
-                                    <p:anim calcmode="lin" valueType="num">
-                                      <p:cBhvr>
-                                        <p:cTn id="91" dur="400" decel="100000" fill="hold"/>
-                                        <p:tgtEl>
-                                          <p:spTgt spid="12"/>
-                                        </p:tgtEl>
-                                        <p:attrNameLst>
-                                          <p:attrName>ppt_y</p:attrName>
-                                        </p:attrNameLst>
-                                      </p:cBhvr>
-                                      <p:tavLst>
-                                        <p:tav tm="0">
-                                          <p:val>
-                                            <p:strVal val="#ppt_y-0.4"/>
-                                          </p:val>
-                                        </p:tav>
-                                        <p:tav tm="100000">
-                                          <p:val>
-                                            <p:strVal val="#ppt_y+0.1"/>
-                                          </p:val>
-                                        </p:tav>
-                                      </p:tavLst>
-                                    </p:anim>
-                                    <p:anim calcmode="lin" valueType="num">
-                                      <p:cBhvr>
-                                        <p:cTn id="92" dur="100" accel="100000" fill="hold">
-                                          <p:stCondLst>
-                                            <p:cond delay="400"/>
-                                          </p:stCondLst>
-                                        </p:cTn>
-                                        <p:tgtEl>
-                                          <p:spTgt spid="12"/>
-                                        </p:tgtEl>
-                                        <p:attrNameLst>
-                                          <p:attrName>ppt_x</p:attrName>
-                                        </p:attrNameLst>
-                                      </p:cBhvr>
-                                      <p:tavLst>
-                                        <p:tav tm="0">
-                                          <p:val>
-                                            <p:strVal val="#ppt_x-0.05"/>
-                                          </p:val>
-                                        </p:tav>
-                                        <p:tav tm="100000">
-                                          <p:val>
-                                            <p:strVal val="#ppt_x"/>
-                                          </p:val>
-                                        </p:tav>
-                                      </p:tavLst>
-                                    </p:anim>
-                                    <p:anim calcmode="lin" valueType="num">
-                                      <p:cBhvr>
-                                        <p:cTn id="93" dur="100" accel="100000" fill="hold">
-                                          <p:stCondLst>
-                                            <p:cond delay="400"/>
-                                          </p:stCondLst>
-                                        </p:cTn>
-                                        <p:tgtEl>
-                                          <p:spTgt spid="12"/>
-                                        </p:tgtEl>
-                                        <p:attrNameLst>
-                                          <p:attrName>ppt_y</p:attrName>
-                                        </p:attrNameLst>
-                                      </p:cBhvr>
-                                      <p:tavLst>
-                                        <p:tav tm="0">
-                                          <p:val>
-                                            <p:strVal val="#ppt_y+0.1"/>
-                                          </p:val>
-                                        </p:tav>
-                                        <p:tav tm="100000">
-                                          <p:val>
-                                            <p:strVal val="#ppt_y"/>
-                                          </p:val>
-                                        </p:tav>
-                                      </p:tavLst>
-                                    </p:anim>
-                                  </p:childTnLst>
-                                </p:cTn>
-                              </p:par>
-                            </p:childTnLst>
-                          </p:cTn>
-                        </p:par>
-                        <p:par>
-                          <p:cTn id="94" fill="hold">
-                            <p:stCondLst>
-                              <p:cond delay="6800"/>
-                            </p:stCondLst>
-                            <p:childTnLst>
-                              <p:par>
-                                <p:cTn id="95" presetID="30" presetClass="entr" presetSubtype="0" fill="hold" grpId="0" nodeType="afterEffect">
-                                  <p:stCondLst>
-                                    <p:cond delay="400"/>
-                                  </p:stCondLst>
-                                  <p:childTnLst>
-                                    <p:set>
-                                      <p:cBhvr>
-                                        <p:cTn id="96" dur="1" fill="hold">
-                                          <p:stCondLst>
-                                            <p:cond delay="0"/>
-                                          </p:stCondLst>
-                                        </p:cTn>
-                                        <p:tgtEl>
-                                          <p:spTgt spid="13"/>
-                                        </p:tgtEl>
-                                        <p:attrNameLst>
-                                          <p:attrName>style.visibility</p:attrName>
-                                        </p:attrNameLst>
-                                      </p:cBhvr>
-                                      <p:to>
-                                        <p:strVal val="visible"/>
-                                      </p:to>
-                                    </p:set>
-                                    <p:animEffect transition="in" filter="fade">
-                                      <p:cBhvr>
-                                        <p:cTn id="97" dur="400" decel="100000"/>
-                                        <p:tgtEl>
-                                          <p:spTgt spid="13"/>
-                                        </p:tgtEl>
-                                      </p:cBhvr>
-                                    </p:animEffect>
-                                    <p:anim calcmode="lin" valueType="num">
-                                      <p:cBhvr>
-                                        <p:cTn id="98" dur="400" decel="100000" fill="hold"/>
-                                        <p:tgtEl>
-                                          <p:spTgt spid="13"/>
-                                        </p:tgtEl>
-                                        <p:attrNameLst>
-                                          <p:attrName>style.rotation</p:attrName>
-                                        </p:attrNameLst>
-                                      </p:cBhvr>
-                                      <p:tavLst>
-                                        <p:tav tm="0">
-                                          <p:val>
-                                            <p:fltVal val="-90"/>
-                                          </p:val>
-                                        </p:tav>
-                                        <p:tav tm="100000">
-                                          <p:val>
-                                            <p:fltVal val="0"/>
-                                          </p:val>
-                                        </p:tav>
-                                      </p:tavLst>
-                                    </p:anim>
-                                    <p:anim calcmode="lin" valueType="num">
-                                      <p:cBhvr>
-                                        <p:cTn id="99" dur="400" decel="100000" fill="hold"/>
-                                        <p:tgtEl>
-                                          <p:spTgt spid="13"/>
-                                        </p:tgtEl>
-                                        <p:attrNameLst>
-                                          <p:attrName>ppt_x</p:attrName>
-                                        </p:attrNameLst>
-                                      </p:cBhvr>
-                                      <p:tavLst>
-                                        <p:tav tm="0">
-                                          <p:val>
-                                            <p:strVal val="#ppt_x+0.4"/>
-                                          </p:val>
-                                        </p:tav>
-                                        <p:tav tm="100000">
-                                          <p:val>
-                                            <p:strVal val="#ppt_x-0.05"/>
-                                          </p:val>
-                                        </p:tav>
-                                      </p:tavLst>
-                                    </p:anim>
-                                    <p:anim calcmode="lin" valueType="num">
-                                      <p:cBhvr>
-                                        <p:cTn id="100" dur="400" decel="100000" fill="hold"/>
-                                        <p:tgtEl>
-                                          <p:spTgt spid="13"/>
-                                        </p:tgtEl>
-                                        <p:attrNameLst>
-                                          <p:attrName>ppt_y</p:attrName>
-                                        </p:attrNameLst>
-                                      </p:cBhvr>
-                                      <p:tavLst>
-                                        <p:tav tm="0">
-                                          <p:val>
-                                            <p:strVal val="#ppt_y-0.4"/>
-                                          </p:val>
-                                        </p:tav>
-                                        <p:tav tm="100000">
-                                          <p:val>
-                                            <p:strVal val="#ppt_y+0.1"/>
-                                          </p:val>
-                                        </p:tav>
-                                      </p:tavLst>
-                                    </p:anim>
-                                    <p:anim calcmode="lin" valueType="num">
-                                      <p:cBhvr>
-                                        <p:cTn id="101" dur="100" accel="100000" fill="hold">
-                                          <p:stCondLst>
-                                            <p:cond delay="400"/>
-                                          </p:stCondLst>
-                                        </p:cTn>
-                                        <p:tgtEl>
-                                          <p:spTgt spid="13"/>
-                                        </p:tgtEl>
-                                        <p:attrNameLst>
-                                          <p:attrName>ppt_x</p:attrName>
-                                        </p:attrNameLst>
-                                      </p:cBhvr>
-                                      <p:tavLst>
-                                        <p:tav tm="0">
-                                          <p:val>
-                                            <p:strVal val="#ppt_x-0.05"/>
-                                          </p:val>
-                                        </p:tav>
-                                        <p:tav tm="100000">
-                                          <p:val>
-                                            <p:strVal val="#ppt_x"/>
-                                          </p:val>
-                                        </p:tav>
-                                      </p:tavLst>
-                                    </p:anim>
-                                    <p:anim calcmode="lin" valueType="num">
-                                      <p:cBhvr>
-                                        <p:cTn id="102" dur="100" accel="100000" fill="hold">
-                                          <p:stCondLst>
-                                            <p:cond delay="400"/>
-                                          </p:stCondLst>
-                                        </p:cTn>
-                                        <p:tgtEl>
-                                          <p:spTgt spid="13"/>
-                                        </p:tgtEl>
-                                        <p:attrNameLst>
-                                          <p:attrName>ppt_y</p:attrName>
-                                        </p:attrNameLst>
-                                      </p:cBhvr>
-                                      <p:tavLst>
-                                        <p:tav tm="0">
-                                          <p:val>
-                                            <p:strVal val="#ppt_y+0.1"/>
-                                          </p:val>
-                                        </p:tav>
-                                        <p:tav tm="100000">
-                                          <p:val>
-                                            <p:strVal val="#ppt_y"/>
-                                          </p:val>
-                                        </p:tav>
-                                      </p:tavLst>
-                                    </p:anim>
-                                  </p:childTnLst>
-                                </p:cTn>
-                              </p:par>
-                            </p:childTnLst>
-                          </p:cTn>
-                        </p:par>
-                        <p:par>
-                          <p:cTn id="103" fill="hold">
-                            <p:stCondLst>
-                              <p:cond delay="7700"/>
-                            </p:stCondLst>
-                            <p:childTnLst>
-                              <p:par>
-                                <p:cTn id="104" presetID="30" presetClass="entr" presetSubtype="0" fill="hold" grpId="0" nodeType="afterEffect">
-                                  <p:stCondLst>
-                                    <p:cond delay="440"/>
-                                  </p:stCondLst>
-                                  <p:childTnLst>
-                                    <p:set>
-                                      <p:cBhvr>
-                                        <p:cTn id="105" dur="1" fill="hold">
-                                          <p:stCondLst>
-                                            <p:cond delay="0"/>
-                                          </p:stCondLst>
-                                        </p:cTn>
-                                        <p:tgtEl>
-                                          <p:spTgt spid="14"/>
-                                        </p:tgtEl>
-                                        <p:attrNameLst>
-                                          <p:attrName>style.visibility</p:attrName>
-                                        </p:attrNameLst>
-                                      </p:cBhvr>
-                                      <p:to>
-                                        <p:strVal val="visible"/>
-                                      </p:to>
-                                    </p:set>
-                                    <p:animEffect transition="in" filter="fade">
-                                      <p:cBhvr>
-                                        <p:cTn id="106" dur="400" decel="100000"/>
-                                        <p:tgtEl>
-                                          <p:spTgt spid="14"/>
-                                        </p:tgtEl>
-                                      </p:cBhvr>
-                                    </p:animEffect>
-                                    <p:anim calcmode="lin" valueType="num">
-                                      <p:cBhvr>
-                                        <p:cTn id="107" dur="400" decel="100000" fill="hold"/>
-                                        <p:tgtEl>
-                                          <p:spTgt spid="14"/>
-                                        </p:tgtEl>
-                                        <p:attrNameLst>
-                                          <p:attrName>style.rotation</p:attrName>
-                                        </p:attrNameLst>
-                                      </p:cBhvr>
-                                      <p:tavLst>
-                                        <p:tav tm="0">
-                                          <p:val>
-                                            <p:fltVal val="-90"/>
-                                          </p:val>
-                                        </p:tav>
-                                        <p:tav tm="100000">
-                                          <p:val>
-                                            <p:fltVal val="0"/>
-                                          </p:val>
-                                        </p:tav>
-                                      </p:tavLst>
-                                    </p:anim>
-                                    <p:anim calcmode="lin" valueType="num">
-                                      <p:cBhvr>
-                                        <p:cTn id="108" dur="400" decel="100000" fill="hold"/>
-                                        <p:tgtEl>
-                                          <p:spTgt spid="14"/>
-                                        </p:tgtEl>
-                                        <p:attrNameLst>
-                                          <p:attrName>ppt_x</p:attrName>
-                                        </p:attrNameLst>
-                                      </p:cBhvr>
-                                      <p:tavLst>
-                                        <p:tav tm="0">
-                                          <p:val>
-                                            <p:strVal val="#ppt_x+0.4"/>
-                                          </p:val>
-                                        </p:tav>
-                                        <p:tav tm="100000">
-                                          <p:val>
-                                            <p:strVal val="#ppt_x-0.05"/>
-                                          </p:val>
-                                        </p:tav>
-                                      </p:tavLst>
-                                    </p:anim>
-                                    <p:anim calcmode="lin" valueType="num">
-                                      <p:cBhvr>
-                                        <p:cTn id="109" dur="400" decel="100000" fill="hold"/>
-                                        <p:tgtEl>
-                                          <p:spTgt spid="14"/>
-                                        </p:tgtEl>
-                                        <p:attrNameLst>
-                                          <p:attrName>ppt_y</p:attrName>
-                                        </p:attrNameLst>
-                                      </p:cBhvr>
-                                      <p:tavLst>
-                                        <p:tav tm="0">
-                                          <p:val>
-                                            <p:strVal val="#ppt_y-0.4"/>
-                                          </p:val>
-                                        </p:tav>
-                                        <p:tav tm="100000">
-                                          <p:val>
-                                            <p:strVal val="#ppt_y+0.1"/>
-                                          </p:val>
-                                        </p:tav>
-                                      </p:tavLst>
-                                    </p:anim>
-                                    <p:anim calcmode="lin" valueType="num">
-                                      <p:cBhvr>
-                                        <p:cTn id="110" dur="100" accel="100000" fill="hold">
-                                          <p:stCondLst>
-                                            <p:cond delay="400"/>
-                                          </p:stCondLst>
-                                        </p:cTn>
-                                        <p:tgtEl>
-                                          <p:spTgt spid="14"/>
-                                        </p:tgtEl>
-                                        <p:attrNameLst>
-                                          <p:attrName>ppt_x</p:attrName>
-                                        </p:attrNameLst>
-                                      </p:cBhvr>
-                                      <p:tavLst>
-                                        <p:tav tm="0">
-                                          <p:val>
-                                            <p:strVal val="#ppt_x-0.05"/>
-                                          </p:val>
-                                        </p:tav>
-                                        <p:tav tm="100000">
-                                          <p:val>
-                                            <p:strVal val="#ppt_x"/>
-                                          </p:val>
-                                        </p:tav>
-                                      </p:tavLst>
-                                    </p:anim>
-                                    <p:anim calcmode="lin" valueType="num">
-                                      <p:cBhvr>
-                                        <p:cTn id="111" dur="100" accel="100000" fill="hold">
-                                          <p:stCondLst>
-                                            <p:cond delay="400"/>
-                                          </p:stCondLst>
-                                        </p:cTn>
-                                        <p:tgtEl>
-                                          <p:spTgt spid="14"/>
-                                        </p:tgtEl>
-                                        <p:attrNameLst>
-                                          <p:attrName>ppt_y</p:attrName>
-                                        </p:attrNameLst>
-                                      </p:cBhvr>
-                                      <p:tavLst>
-                                        <p:tav tm="0">
-                                          <p:val>
-                                            <p:strVal val="#ppt_y+0.1"/>
-                                          </p:val>
-                                        </p:tav>
-                                        <p:tav tm="100000">
-                                          <p:val>
-                                            <p:strVal val="#ppt_y"/>
-                                          </p:val>
-                                        </p:tav>
-                                      </p:tavLst>
-                                    </p:anim>
-                                  </p:childTnLst>
-                                </p:cTn>
-                              </p:par>
-                            </p:childTnLst>
-                          </p:cTn>
-                        </p:par>
-                        <p:par>
-                          <p:cTn id="112" fill="hold">
-                            <p:stCondLst>
-                              <p:cond delay="8640"/>
-                            </p:stCondLst>
-                            <p:childTnLst>
-                              <p:par>
-                                <p:cTn id="113" presetID="30" presetClass="entr" presetSubtype="0" fill="hold" grpId="0" nodeType="afterEffect">
-                                  <p:stCondLst>
-                                    <p:cond delay="480"/>
-                                  </p:stCondLst>
-                                  <p:childTnLst>
-                                    <p:set>
-                                      <p:cBhvr>
-                                        <p:cTn id="114" dur="1" fill="hold">
-                                          <p:stCondLst>
-                                            <p:cond delay="0"/>
-                                          </p:stCondLst>
-                                        </p:cTn>
-                                        <p:tgtEl>
-                                          <p:spTgt spid="15"/>
-                                        </p:tgtEl>
-                                        <p:attrNameLst>
-                                          <p:attrName>style.visibility</p:attrName>
-                                        </p:attrNameLst>
-                                      </p:cBhvr>
-                                      <p:to>
-                                        <p:strVal val="visible"/>
-                                      </p:to>
-                                    </p:set>
-                                    <p:animEffect transition="in" filter="fade">
-                                      <p:cBhvr>
-                                        <p:cTn id="115" dur="400" decel="100000"/>
-                                        <p:tgtEl>
-                                          <p:spTgt spid="15"/>
-                                        </p:tgtEl>
-                                      </p:cBhvr>
-                                    </p:animEffect>
-                                    <p:anim calcmode="lin" valueType="num">
-                                      <p:cBhvr>
-                                        <p:cTn id="116" dur="400" decel="100000" fill="hold"/>
-                                        <p:tgtEl>
-                                          <p:spTgt spid="15"/>
-                                        </p:tgtEl>
-                                        <p:attrNameLst>
-                                          <p:attrName>style.rotation</p:attrName>
-                                        </p:attrNameLst>
-                                      </p:cBhvr>
-                                      <p:tavLst>
-                                        <p:tav tm="0">
-                                          <p:val>
-                                            <p:fltVal val="-90"/>
-                                          </p:val>
-                                        </p:tav>
-                                        <p:tav tm="100000">
-                                          <p:val>
-                                            <p:fltVal val="0"/>
-                                          </p:val>
-                                        </p:tav>
-                                      </p:tavLst>
-                                    </p:anim>
-                                    <p:anim calcmode="lin" valueType="num">
-                                      <p:cBhvr>
-                                        <p:cTn id="117" dur="400" decel="100000" fill="hold"/>
-                                        <p:tgtEl>
-                                          <p:spTgt spid="15"/>
-                                        </p:tgtEl>
-                                        <p:attrNameLst>
-                                          <p:attrName>ppt_x</p:attrName>
-                                        </p:attrNameLst>
-                                      </p:cBhvr>
-                                      <p:tavLst>
-                                        <p:tav tm="0">
-                                          <p:val>
-                                            <p:strVal val="#ppt_x+0.4"/>
-                                          </p:val>
-                                        </p:tav>
-                                        <p:tav tm="100000">
-                                          <p:val>
-                                            <p:strVal val="#ppt_x-0.05"/>
-                                          </p:val>
-                                        </p:tav>
-                                      </p:tavLst>
-                                    </p:anim>
-                                    <p:anim calcmode="lin" valueType="num">
-                                      <p:cBhvr>
-                                        <p:cTn id="118" dur="400" decel="100000" fill="hold"/>
-                                        <p:tgtEl>
-                                          <p:spTgt spid="15"/>
-                                        </p:tgtEl>
-                                        <p:attrNameLst>
-                                          <p:attrName>ppt_y</p:attrName>
-                                        </p:attrNameLst>
-                                      </p:cBhvr>
-                                      <p:tavLst>
-                                        <p:tav tm="0">
-                                          <p:val>
-                                            <p:strVal val="#ppt_y-0.4"/>
-                                          </p:val>
-                                        </p:tav>
-                                        <p:tav tm="100000">
-                                          <p:val>
-                                            <p:strVal val="#ppt_y+0.1"/>
-                                          </p:val>
-                                        </p:tav>
-                                      </p:tavLst>
-                                    </p:anim>
-                                    <p:anim calcmode="lin" valueType="num">
-                                      <p:cBhvr>
-                                        <p:cTn id="119" dur="100" accel="100000" fill="hold">
-                                          <p:stCondLst>
-                                            <p:cond delay="400"/>
-                                          </p:stCondLst>
-                                        </p:cTn>
-                                        <p:tgtEl>
-                                          <p:spTgt spid="15"/>
-                                        </p:tgtEl>
-                                        <p:attrNameLst>
-                                          <p:attrName>ppt_x</p:attrName>
-                                        </p:attrNameLst>
-                                      </p:cBhvr>
-                                      <p:tavLst>
-                                        <p:tav tm="0">
-                                          <p:val>
-                                            <p:strVal val="#ppt_x-0.05"/>
-                                          </p:val>
-                                        </p:tav>
-                                        <p:tav tm="100000">
-                                          <p:val>
-                                            <p:strVal val="#ppt_x"/>
-                                          </p:val>
-                                        </p:tav>
-                                      </p:tavLst>
-                                    </p:anim>
-                                    <p:anim calcmode="lin" valueType="num">
-                                      <p:cBhvr>
-                                        <p:cTn id="120" dur="100" accel="100000" fill="hold">
-                                          <p:stCondLst>
-                                            <p:cond delay="400"/>
-                                          </p:stCondLst>
-                                        </p:cTn>
-                                        <p:tgtEl>
-                                          <p:spTgt spid="15"/>
-                                        </p:tgtEl>
-                                        <p:attrNameLst>
-                                          <p:attrName>ppt_y</p:attrName>
-                                        </p:attrNameLst>
-                                      </p:cBhvr>
-                                      <p:tavLst>
-                                        <p:tav tm="0">
-                                          <p:val>
-                                            <p:strVal val="#ppt_y+0.1"/>
-                                          </p:val>
-                                        </p:tav>
-                                        <p:tav tm="100000">
-                                          <p:val>
-                                            <p:strVal val="#ppt_y"/>
-                                          </p:val>
-                                        </p:tav>
-                                      </p:tavLst>
-                                    </p:anim>
-                                  </p:childTnLst>
-                                </p:cTn>
-                              </p:par>
-                            </p:childTnLst>
-                          </p:cTn>
-                        </p:par>
-                        <p:par>
-                          <p:cTn id="121" fill="hold">
-                            <p:stCondLst>
-                              <p:cond delay="9620"/>
-                            </p:stCondLst>
-                            <p:childTnLst>
-                              <p:par>
-                                <p:cTn id="122" presetID="30" presetClass="entr" presetSubtype="0" fill="hold" grpId="0" nodeType="afterEffect">
-                                  <p:stCondLst>
-                                    <p:cond delay="520"/>
-                                  </p:stCondLst>
-                                  <p:childTnLst>
-                                    <p:set>
-                                      <p:cBhvr>
-                                        <p:cTn id="123" dur="1" fill="hold">
-                                          <p:stCondLst>
-                                            <p:cond delay="0"/>
-                                          </p:stCondLst>
-                                        </p:cTn>
-                                        <p:tgtEl>
-                                          <p:spTgt spid="16"/>
-                                        </p:tgtEl>
-                                        <p:attrNameLst>
-                                          <p:attrName>style.visibility</p:attrName>
-                                        </p:attrNameLst>
-                                      </p:cBhvr>
-                                      <p:to>
-                                        <p:strVal val="visible"/>
-                                      </p:to>
-                                    </p:set>
-                                    <p:animEffect transition="in" filter="fade">
-                                      <p:cBhvr>
-                                        <p:cTn id="124" dur="400" decel="100000"/>
-                                        <p:tgtEl>
-                                          <p:spTgt spid="16"/>
-                                        </p:tgtEl>
-                                      </p:cBhvr>
-                                    </p:animEffect>
-                                    <p:anim calcmode="lin" valueType="num">
-                                      <p:cBhvr>
-                                        <p:cTn id="125" dur="400" decel="100000" fill="hold"/>
-                                        <p:tgtEl>
-                                          <p:spTgt spid="16"/>
-                                        </p:tgtEl>
-                                        <p:attrNameLst>
-                                          <p:attrName>style.rotation</p:attrName>
-                                        </p:attrNameLst>
-                                      </p:cBhvr>
-                                      <p:tavLst>
-                                        <p:tav tm="0">
-                                          <p:val>
-                                            <p:fltVal val="-90"/>
-                                          </p:val>
-                                        </p:tav>
-                                        <p:tav tm="100000">
-                                          <p:val>
-                                            <p:fltVal val="0"/>
-                                          </p:val>
-                                        </p:tav>
-                                      </p:tavLst>
-                                    </p:anim>
-                                    <p:anim calcmode="lin" valueType="num">
-                                      <p:cBhvr>
-                                        <p:cTn id="126" dur="400" decel="100000" fill="hold"/>
-                                        <p:tgtEl>
-                                          <p:spTgt spid="16"/>
-                                        </p:tgtEl>
-                                        <p:attrNameLst>
-                                          <p:attrName>ppt_x</p:attrName>
-                                        </p:attrNameLst>
-                                      </p:cBhvr>
-                                      <p:tavLst>
-                                        <p:tav tm="0">
-                                          <p:val>
-                                            <p:strVal val="#ppt_x+0.4"/>
-                                          </p:val>
-                                        </p:tav>
-                                        <p:tav tm="100000">
-                                          <p:val>
-                                            <p:strVal val="#ppt_x-0.05"/>
-                                          </p:val>
-                                        </p:tav>
-                                      </p:tavLst>
-                                    </p:anim>
-                                    <p:anim calcmode="lin" valueType="num">
-                                      <p:cBhvr>
-                                        <p:cTn id="127" dur="400" decel="100000" fill="hold"/>
-                                        <p:tgtEl>
-                                          <p:spTgt spid="16"/>
-                                        </p:tgtEl>
-                                        <p:attrNameLst>
-                                          <p:attrName>ppt_y</p:attrName>
-                                        </p:attrNameLst>
-                                      </p:cBhvr>
-                                      <p:tavLst>
-                                        <p:tav tm="0">
-                                          <p:val>
-                                            <p:strVal val="#ppt_y-0.4"/>
-                                          </p:val>
-                                        </p:tav>
-                                        <p:tav tm="100000">
-                                          <p:val>
-                                            <p:strVal val="#ppt_y+0.1"/>
-                                          </p:val>
-                                        </p:tav>
-                                      </p:tavLst>
-                                    </p:anim>
-                                    <p:anim calcmode="lin" valueType="num">
-                                      <p:cBhvr>
-                                        <p:cTn id="128" dur="100" accel="100000" fill="hold">
-                                          <p:stCondLst>
-                                            <p:cond delay="400"/>
-                                          </p:stCondLst>
-                                        </p:cTn>
-                                        <p:tgtEl>
-                                          <p:spTgt spid="16"/>
-                                        </p:tgtEl>
-                                        <p:attrNameLst>
-                                          <p:attrName>ppt_x</p:attrName>
-                                        </p:attrNameLst>
-                                      </p:cBhvr>
-                                      <p:tavLst>
-                                        <p:tav tm="0">
-                                          <p:val>
-                                            <p:strVal val="#ppt_x-0.05"/>
-                                          </p:val>
-                                        </p:tav>
-                                        <p:tav tm="100000">
-                                          <p:val>
-                                            <p:strVal val="#ppt_x"/>
-                                          </p:val>
-                                        </p:tav>
-                                      </p:tavLst>
-                                    </p:anim>
-                                    <p:anim calcmode="lin" valueType="num">
-                                      <p:cBhvr>
-                                        <p:cTn id="129" dur="100" accel="100000" fill="hold">
-                                          <p:stCondLst>
-                                            <p:cond delay="400"/>
-                                          </p:stCondLst>
-                                        </p:cTn>
-                                        <p:tgtEl>
-                                          <p:spTgt spid="16"/>
-                                        </p:tgtEl>
-                                        <p:attrNameLst>
-                                          <p:attrName>ppt_y</p:attrName>
-                                        </p:attrNameLst>
-                                      </p:cBhvr>
-                                      <p:tavLst>
-                                        <p:tav tm="0">
-                                          <p:val>
-                                            <p:strVal val="#ppt_y+0.1"/>
-                                          </p:val>
-                                        </p:tav>
-                                        <p:tav tm="100000">
-                                          <p:val>
-                                            <p:strVal val="#ppt_y"/>
-                                          </p:val>
-                                        </p:tav>
-                                      </p:tavLst>
-                                    </p:anim>
-                                  </p:childTnLst>
-                                </p:cTn>
-                              </p:par>
-                            </p:childTnLst>
-                          </p:cTn>
-                        </p:par>
-                      </p:childTnLst>
-                    </p:cTn>
-                  </p:par>
-                </p:childTnLst>
-              </p:cTn>
-              <p:prevCondLst>
-                <p:cond evt="onPrev" delay="0">
-                  <p:tgtEl>
-                    <p:sldTgt/>
-                  </p:tgtEl>
-                </p:cond>
-              </p:prevCondLst>
-              <p:nextCondLst>
-                <p:cond evt="onNext" delay="0">
-                  <p:tgtEl>
-                    <p:sldTgt/>
-                  </p:tgtEl>
-                </p:cond>
-              </p:nextCondLst>
-            </p:seq>
-          </p:childTnLst>
-        </p:cTn>
-      </p:par>
-    </p:tnLst>
-    <p:bldLst>
-      <p:bldP spid="3" grpId="0" animBg="1"/>
-      <p:bldP spid="4" grpId="0"/>
-      <p:bldP spid="5" grpId="0"/>
-      <p:bldP spid="6" grpId="0"/>
-      <p:bldP spid="7" grpId="0" animBg="1"/>
-      <p:bldP spid="8" grpId="0"/>
-      <p:bldP spid="9" grpId="0" animBg="1"/>
-      <p:bldP spid="10" grpId="0"/>
-      <p:bldP spid="11" grpId="0" animBg="1"/>
-      <p:bldP spid="12" grpId="0"/>
-      <p:bldP spid="13" grpId="0" animBg="1"/>
-      <p:bldP spid="14" grpId="0" animBg="1"/>
-      <p:bldP spid="15" grpId="0"/>
-      <p:bldP spid="16" grpId="0"/>
-    </p:bldLst>
-  </p:timing>
 </p:sld>
 </file>
 
@@ -9045,13 +5717,13 @@
   <p:clrMapOvr>
     <a:masterClrMapping/>
   </p:clrMapOvr>
-  <mc:AlternateContent xmlns:mc="http://schemas.openxmlformats.org/markup-compatibility/2006">
-    <mc:Choice xmlns:p14="http://schemas.microsoft.com/office/powerpoint/2010/main" Requires="p14">
+  <mc:AlternateContent xmlns:mc="http://schemas.openxmlformats.org/markup-compatibility/2006" xmlns:p14="http://schemas.microsoft.com/office/powerpoint/2010/main">
+    <mc:Choice Requires="p14">
       <p:transition spd="med" p14:dur="700">
         <p14:reveal/>
       </p:transition>
     </mc:Choice>
-    <mc:Fallback>
+    <mc:Fallback xmlns="">
       <p:transition spd="med">
         <p:fade/>
       </p:transition>
@@ -10234,13 +6906,13 @@
   <p:clrMapOvr>
     <a:masterClrMapping/>
   </p:clrMapOvr>
-  <mc:AlternateContent xmlns:mc="http://schemas.openxmlformats.org/markup-compatibility/2006">
-    <mc:Choice xmlns:p14="http://schemas.microsoft.com/office/powerpoint/2010/main" Requires="p14">
+  <mc:AlternateContent xmlns:mc="http://schemas.openxmlformats.org/markup-compatibility/2006" xmlns:p14="http://schemas.microsoft.com/office/powerpoint/2010/main">
+    <mc:Choice Requires="p14">
       <p:transition spd="med" p14:dur="700">
         <p14:reveal/>
       </p:transition>
     </mc:Choice>
-    <mc:Fallback>
+    <mc:Fallback xmlns="">
       <p:transition spd="med">
         <p:fade/>
       </p:transition>
@@ -11423,13 +8095,13 @@
   <p:clrMapOvr>
     <a:masterClrMapping/>
   </p:clrMapOvr>
-  <mc:AlternateContent xmlns:mc="http://schemas.openxmlformats.org/markup-compatibility/2006">
-    <mc:Choice xmlns:p14="http://schemas.microsoft.com/office/powerpoint/2010/main" Requires="p14">
+  <mc:AlternateContent xmlns:mc="http://schemas.openxmlformats.org/markup-compatibility/2006" xmlns:p14="http://schemas.microsoft.com/office/powerpoint/2010/main">
+    <mc:Choice Requires="p14">
       <p:transition spd="med" p14:dur="700">
         <p14:reveal/>
       </p:transition>
     </mc:Choice>
-    <mc:Fallback>
+    <mc:Fallback xmlns="">
       <p:transition spd="med">
         <p:fade/>
       </p:transition>
@@ -12216,13 +8888,13 @@
   <p:clrMapOvr>
     <a:masterClrMapping/>
   </p:clrMapOvr>
-  <mc:AlternateContent xmlns:mc="http://schemas.openxmlformats.org/markup-compatibility/2006">
-    <mc:Choice xmlns:p14="http://schemas.microsoft.com/office/powerpoint/2010/main" Requires="p14">
+  <mc:AlternateContent xmlns:mc="http://schemas.openxmlformats.org/markup-compatibility/2006" xmlns:p14="http://schemas.microsoft.com/office/powerpoint/2010/main">
+    <mc:Choice Requires="p14">
       <p:transition spd="med" p14:dur="700">
         <p14:reveal/>
       </p:transition>
     </mc:Choice>
-    <mc:Fallback>
+    <mc:Fallback xmlns="">
       <p:transition spd="med">
         <p:fade/>
       </p:transition>
@@ -12447,13 +9119,31 @@
               </a:spcAft>
             </a:pPr>
             <a:r>
-              <a:rPr sz="4200" b="0">
+              <a:rPr sz="4200" b="0" dirty="0">
                 <a:solidFill>
                   <a:srgbClr val="F4F0FB"/>
                 </a:solidFill>
                 <a:latin typeface="Segoe UI Light"/>
               </a:rPr>
-              <a:t>Du entscheidest.</a:t>
+              <a:t>Du </a:t>
+            </a:r>
+            <a:r>
+              <a:rPr sz="4200" b="0" dirty="0" err="1">
+                <a:solidFill>
+                  <a:srgbClr val="F4F0FB"/>
+                </a:solidFill>
+                <a:latin typeface="Segoe UI Light"/>
+              </a:rPr>
+              <a:t>entscheidest</a:t>
+            </a:r>
+            <a:r>
+              <a:rPr sz="4200" b="0" dirty="0">
+                <a:solidFill>
+                  <a:srgbClr val="F4F0FB"/>
+                </a:solidFill>
+                <a:latin typeface="Segoe UI Light"/>
+              </a:rPr>
+              <a:t>.</a:t>
             </a:r>
           </a:p>
         </p:txBody>
@@ -12580,22 +9270,112 @@
               </a:spcAft>
             </a:pPr>
             <a:r>
-              <a:rPr sz="1700" b="0">
+              <a:rPr sz="1700" b="0" dirty="0">
                 <a:solidFill>
                   <a:srgbClr val="F4F0FB"/>
                 </a:solidFill>
                 <a:latin typeface="Segoe UI"/>
               </a:rPr>
-              <a:t>Die Vorschau läuft. </a:t>
-            </a:r>
-            <a:r>
-              <a:rPr sz="1700" b="1">
+              <a:t>Die </a:t>
+            </a:r>
+            <a:r>
+              <a:rPr sz="1700" b="0" dirty="0" err="1">
                 <a:solidFill>
                   <a:srgbClr val="F4F0FB"/>
                 </a:solidFill>
                 <a:latin typeface="Segoe UI"/>
               </a:rPr>
-              <a:t>Du hast sie selbst geklickt.</a:t>
+              <a:t>Vorschau</a:t>
+            </a:r>
+            <a:r>
+              <a:rPr sz="1700" b="0" dirty="0">
+                <a:solidFill>
+                  <a:srgbClr val="F4F0FB"/>
+                </a:solidFill>
+                <a:latin typeface="Segoe UI"/>
+              </a:rPr>
+              <a:t> </a:t>
+            </a:r>
+            <a:r>
+              <a:rPr sz="1700" b="0" dirty="0" err="1">
+                <a:solidFill>
+                  <a:srgbClr val="F4F0FB"/>
+                </a:solidFill>
+                <a:latin typeface="Segoe UI"/>
+              </a:rPr>
+              <a:t>läuft</a:t>
+            </a:r>
+            <a:r>
+              <a:rPr sz="1700" b="0" dirty="0">
+                <a:solidFill>
+                  <a:srgbClr val="F4F0FB"/>
+                </a:solidFill>
+                <a:latin typeface="Segoe UI"/>
+              </a:rPr>
+              <a:t>. </a:t>
+            </a:r>
+            <a:r>
+              <a:rPr sz="1700" b="1" dirty="0">
+                <a:solidFill>
+                  <a:srgbClr val="F4F0FB"/>
+                </a:solidFill>
+                <a:latin typeface="Segoe UI"/>
+              </a:rPr>
+              <a:t>Du hast </a:t>
+            </a:r>
+            <a:r>
+              <a:rPr sz="1700" b="1" dirty="0" err="1">
+                <a:solidFill>
+                  <a:srgbClr val="F4F0FB"/>
+                </a:solidFill>
+                <a:latin typeface="Segoe UI"/>
+              </a:rPr>
+              <a:t>sie</a:t>
+            </a:r>
+            <a:r>
+              <a:rPr sz="1700" b="1" dirty="0">
+                <a:solidFill>
+                  <a:srgbClr val="F4F0FB"/>
+                </a:solidFill>
+                <a:latin typeface="Segoe UI"/>
+              </a:rPr>
+              <a:t> </a:t>
+            </a:r>
+            <a:r>
+              <a:rPr sz="1700" b="1" dirty="0" err="1">
+                <a:solidFill>
+                  <a:srgbClr val="F4F0FB"/>
+                </a:solidFill>
+                <a:latin typeface="Segoe UI"/>
+              </a:rPr>
+              <a:t>selbst</a:t>
+            </a:r>
+            <a:r>
+              <a:rPr sz="1700" b="1" dirty="0">
+                <a:solidFill>
+                  <a:srgbClr val="F4F0FB"/>
+                </a:solidFill>
+                <a:latin typeface="Segoe UI"/>
+              </a:rPr>
+              <a:t> </a:t>
+            </a:r>
+            <a:r>
+              <a:rPr sz="1700" b="1" dirty="0" err="1">
+                <a:solidFill>
+                  <a:srgbClr val="F4F0FB"/>
+                </a:solidFill>
+                <a:latin typeface="Segoe UI"/>
+              </a:rPr>
+              <a:t>geklickt</a:t>
+            </a:r>
+            <a:r>
+              <a:rPr sz="1700" b="1" dirty="0">
+                <a:solidFill>
+                  <a:srgbClr val="F4F0FB"/>
+                </a:solidFill>
+                <a:latin typeface="Segoe UI"/>
+              </a:rPr>
+              <a:t>.</a:t>
             </a:r>
           </a:p>
         </p:txBody>
@@ -12834,13 +9614,13 @@
   <p:clrMapOvr>
     <a:masterClrMapping/>
   </p:clrMapOvr>
-  <mc:AlternateContent xmlns:mc="http://schemas.openxmlformats.org/markup-compatibility/2006">
-    <mc:Choice xmlns:p14="http://schemas.microsoft.com/office/powerpoint/2010/main" Requires="p14">
+  <mc:AlternateContent xmlns:mc="http://schemas.openxmlformats.org/markup-compatibility/2006" xmlns:p14="http://schemas.microsoft.com/office/powerpoint/2010/main">
+    <mc:Choice Requires="p14">
       <p:transition spd="med" p14:dur="700">
         <p14:reveal/>
       </p:transition>
     </mc:Choice>
-    <mc:Fallback>
+    <mc:Fallback xmlns="">
       <p:transition spd="med">
         <p:fade/>
       </p:transition>
@@ -13084,7 +9864,7 @@
           <a:p>
             <a:pPr algn="r"/>
             <a:r>
-              <a:rPr sz="1800" b="1">
+              <a:rPr sz="1800" b="1" dirty="0">
                 <a:solidFill>
                   <a:srgbClr val="F4F0FB"/>
                 </a:solidFill>
@@ -13093,13 +9873,26 @@
               <a:t>FINELLI</a:t>
             </a:r>
             <a:r>
-              <a:rPr sz="900">
+              <a:rPr sz="900" dirty="0">
                 <a:solidFill>
                   <a:srgbClr val="BB92FF"/>
                 </a:solidFill>
               </a:rPr>
-              <a:t> ●</a:t>
-            </a:r>
+              <a:t> </a:t>
+            </a:r>
+            <a:r>
+              <a:rPr lang="de-CH" sz="900" dirty="0">
+                <a:solidFill>
+                  <a:srgbClr val="BB92FF"/>
+                </a:solidFill>
+              </a:rPr>
+              <a:t>●</a:t>
+            </a:r>
+            <a:endParaRPr sz="900" dirty="0">
+              <a:solidFill>
+                <a:srgbClr val="BB92FF"/>
+              </a:solidFill>
+            </a:endParaRPr>
           </a:p>
         </p:txBody>
       </p:sp>
@@ -13940,13 +10733,13 @@
   <p:clrMapOvr>
     <a:masterClrMapping/>
   </p:clrMapOvr>
-  <mc:AlternateContent xmlns:mc="http://schemas.openxmlformats.org/markup-compatibility/2006">
-    <mc:Choice xmlns:p14="http://schemas.microsoft.com/office/powerpoint/2010/main" Requires="p14">
+  <mc:AlternateContent xmlns:mc="http://schemas.openxmlformats.org/markup-compatibility/2006" xmlns:p14="http://schemas.microsoft.com/office/powerpoint/2010/main">
+    <mc:Choice Requires="p14">
       <p:transition spd="med" p14:dur="700">
         <p14:reveal/>
       </p:transition>
     </mc:Choice>
-    <mc:Fallback>
+    <mc:Fallback xmlns="">
       <p:transition spd="med">
         <p:fade/>
       </p:transition>
@@ -14808,13 +11601,13 @@
   <p:clrMapOvr>
     <a:masterClrMapping/>
   </p:clrMapOvr>
-  <mc:AlternateContent xmlns:mc="http://schemas.openxmlformats.org/markup-compatibility/2006">
-    <mc:Choice xmlns:p14="http://schemas.microsoft.com/office/powerpoint/2010/main" Requires="p14">
+  <mc:AlternateContent xmlns:mc="http://schemas.openxmlformats.org/markup-compatibility/2006" xmlns:p14="http://schemas.microsoft.com/office/powerpoint/2010/main">
+    <mc:Choice Requires="p14">
       <p:transition spd="med" p14:dur="700">
         <p14:reveal/>
       </p:transition>
     </mc:Choice>
-    <mc:Fallback>
+    <mc:Fallback xmlns="">
       <p:transition spd="med">
         <p:fade/>
       </p:transition>
@@ -16041,13 +12834,13 @@
   <p:clrMapOvr>
     <a:masterClrMapping/>
   </p:clrMapOvr>
-  <mc:AlternateContent xmlns:mc="http://schemas.openxmlformats.org/markup-compatibility/2006">
-    <mc:Choice xmlns:p14="http://schemas.microsoft.com/office/powerpoint/2010/main" Requires="p14">
+  <mc:AlternateContent xmlns:mc="http://schemas.openxmlformats.org/markup-compatibility/2006" xmlns:p14="http://schemas.microsoft.com/office/powerpoint/2010/main">
+    <mc:Choice Requires="p14">
       <p:transition spd="med" p14:dur="700">
         <p14:reveal/>
       </p:transition>
     </mc:Choice>
-    <mc:Fallback>
+    <mc:Fallback xmlns="">
       <p:transition spd="med">
         <p:fade/>
       </p:transition>
@@ -16809,8 +13602,8 @@
         </p:nvSpPr>
         <p:spPr>
           <a:xfrm>
-            <a:off x="5143500" y="2674620"/>
-            <a:ext cx="1965960" cy="1965960"/>
+            <a:off x="5000687" y="2670048"/>
+            <a:ext cx="2251586" cy="1970532"/>
           </a:xfrm>
           <a:prstGeom prst="ellipse">
             <a:avLst/>
@@ -16854,8 +13647,8 @@
         </p:nvSpPr>
         <p:spPr>
           <a:xfrm>
-            <a:off x="4663440" y="3063240"/>
-            <a:ext cx="2926080" cy="1463040"/>
+            <a:off x="4526281" y="3346802"/>
+            <a:ext cx="3200399" cy="630942"/>
           </a:xfrm>
           <a:prstGeom prst="rect">
             <a:avLst/>
@@ -16874,7 +13667,7 @@
               </a:spcAft>
             </a:pPr>
             <a:r>
-              <a:rPr sz="1700" b="1">
+              <a:rPr sz="1700" b="1" dirty="0">
                 <a:solidFill>
                   <a:srgbClr val="FFFFFF"/>
                 </a:solidFill>
@@ -16890,7 +13683,7 @@
               </a:spcAft>
             </a:pPr>
             <a:r>
-              <a:rPr sz="1300" b="0">
+              <a:rPr sz="1300" b="0" dirty="0">
                 <a:solidFill>
                   <a:srgbClr val="EADFFB"/>
                 </a:solidFill>
@@ -17237,13 +14030,13 @@
   <p:clrMapOvr>
     <a:masterClrMapping/>
   </p:clrMapOvr>
-  <mc:AlternateContent xmlns:mc="http://schemas.openxmlformats.org/markup-compatibility/2006">
-    <mc:Choice xmlns:p14="http://schemas.microsoft.com/office/powerpoint/2010/main" Requires="p14">
+  <mc:AlternateContent xmlns:mc="http://schemas.openxmlformats.org/markup-compatibility/2006" xmlns:p14="http://schemas.microsoft.com/office/powerpoint/2010/main">
+    <mc:Choice Requires="p14">
       <p:transition spd="med" p14:dur="700">
         <p14:reveal/>
       </p:transition>
     </mc:Choice>
-    <mc:Fallback>
+    <mc:Fallback xmlns="">
       <p:transition spd="med">
         <p:fade/>
       </p:transition>
@@ -18940,13 +15733,13 @@
   <p:clrMapOvr>
     <a:masterClrMapping/>
   </p:clrMapOvr>
-  <mc:AlternateContent xmlns:mc="http://schemas.openxmlformats.org/markup-compatibility/2006">
-    <mc:Choice xmlns:p14="http://schemas.microsoft.com/office/powerpoint/2010/main" Requires="p14">
+  <mc:AlternateContent xmlns:mc="http://schemas.openxmlformats.org/markup-compatibility/2006" xmlns:p14="http://schemas.microsoft.com/office/powerpoint/2010/main">
+    <mc:Choice Requires="p14">
       <p:transition spd="med" p14:dur="700">
         <p14:reveal/>
       </p:transition>
     </mc:Choice>
-    <mc:Fallback>
+    <mc:Fallback xmlns="">
       <p:transition spd="med">
         <p:fade/>
       </p:transition>
@@ -20081,13 +16874,13 @@
   <p:clrMapOvr>
     <a:masterClrMapping/>
   </p:clrMapOvr>
-  <mc:AlternateContent xmlns:mc="http://schemas.openxmlformats.org/markup-compatibility/2006">
-    <mc:Choice xmlns:p14="http://schemas.microsoft.com/office/powerpoint/2010/main" Requires="p14">
+  <mc:AlternateContent xmlns:mc="http://schemas.openxmlformats.org/markup-compatibility/2006" xmlns:p14="http://schemas.microsoft.com/office/powerpoint/2010/main">
+    <mc:Choice Requires="p14">
       <p:transition spd="med" p14:dur="700">
         <p14:reveal/>
       </p:transition>
     </mc:Choice>
-    <mc:Fallback>
+    <mc:Fallback xmlns="">
       <p:transition spd="med">
         <p:fade/>
       </p:transition>
@@ -21251,13 +18044,13 @@
   <p:clrMapOvr>
     <a:masterClrMapping/>
   </p:clrMapOvr>
-  <mc:AlternateContent xmlns:mc="http://schemas.openxmlformats.org/markup-compatibility/2006">
-    <mc:Choice xmlns:p14="http://schemas.microsoft.com/office/powerpoint/2010/main" Requires="p14">
+  <mc:AlternateContent xmlns:mc="http://schemas.openxmlformats.org/markup-compatibility/2006" xmlns:p14="http://schemas.microsoft.com/office/powerpoint/2010/main">
+    <mc:Choice Requires="p14">
       <p:transition spd="med" p14:dur="700">
         <p14:reveal/>
       </p:transition>
     </mc:Choice>
-    <mc:Fallback>
+    <mc:Fallback xmlns="">
       <p:transition spd="med">
         <p:fade/>
       </p:transition>
@@ -22078,13 +18871,13 @@
   <p:clrMapOvr>
     <a:masterClrMapping/>
   </p:clrMapOvr>
-  <mc:AlternateContent xmlns:mc="http://schemas.openxmlformats.org/markup-compatibility/2006">
-    <mc:Choice xmlns:p14="http://schemas.microsoft.com/office/powerpoint/2010/main" Requires="p14">
+  <mc:AlternateContent xmlns:mc="http://schemas.openxmlformats.org/markup-compatibility/2006" xmlns:p14="http://schemas.microsoft.com/office/powerpoint/2010/main">
+    <mc:Choice Requires="p14">
       <p:transition spd="med" p14:dur="700">
         <p14:reveal/>
       </p:transition>
     </mc:Choice>
-    <mc:Fallback>
+    <mc:Fallback xmlns="">
       <p:transition spd="med">
         <p:fade/>
       </p:transition>

</xml_diff>